<commit_message>
add metadata and rerank functionality in rag retrieval
</commit_message>
<xml_diff>
--- a/AI-ML-DL/04- GenAI - Langchain/06- Vectorstores.lc.pptx
+++ b/AI-ML-DL/04- GenAI - Langchain/06- Vectorstores.lc.pptx
@@ -238,7 +238,7 @@
       </p14:sectionLst>
     </p:ext>
     <p:ext uri="{EFAFB233-063F-42B5-8137-9DF3F51BA10A}">
-      <p15:sldGuideLst xmlns="" xmlns:p15="http://schemas.microsoft.com/office/powerpoint/2012/main"/>
+      <p15:sldGuideLst xmlns:p15="http://schemas.microsoft.com/office/powerpoint/2012/main" xmlns=""/>
     </p:ext>
   </p:extLst>
 </p:presentation>
@@ -336,7 +336,7 @@
           <a:p>
             <a:fld id="{BF58C147-18C2-4D33-BF56-E30CA9229223}" type="datetimeFigureOut">
               <a:rPr lang="en-IN" smtClean="0"/>
-              <a:t>24-02-2026</a:t>
+              <a:t>07-04-2026</a:t>
             </a:fld>
             <a:endParaRPr lang="en-IN" dirty="0"/>
           </a:p>
@@ -1789,7 +1789,7 @@
         <p:cNvPr id="1" name="">
           <a:extLst>
             <a:ext uri="{FF2B5EF4-FFF2-40B4-BE49-F238E27FC236}">
-              <a16:creationId xmlns="" xmlns:a16="http://schemas.microsoft.com/office/drawing/2014/main" id="{44662A70-DFBD-127F-D5CC-9B0F1A56272C}"/>
+              <a16:creationId xmlns:a16="http://schemas.microsoft.com/office/drawing/2014/main" xmlns="" id="{44662A70-DFBD-127F-D5CC-9B0F1A56272C}"/>
             </a:ext>
           </a:extLst>
         </p:cNvPr>
@@ -1809,7 +1809,7 @@
           <p:cNvPr id="2" name="Slide Image Placeholder 1">
             <a:extLst>
               <a:ext uri="{FF2B5EF4-FFF2-40B4-BE49-F238E27FC236}">
-                <a16:creationId xmlns="" xmlns:a16="http://schemas.microsoft.com/office/drawing/2014/main" id="{6F420B84-9022-B7D2-9C67-0FDA0433D49D}"/>
+                <a16:creationId xmlns:a16="http://schemas.microsoft.com/office/drawing/2014/main" xmlns="" id="{6F420B84-9022-B7D2-9C67-0FDA0433D49D}"/>
               </a:ext>
             </a:extLst>
           </p:cNvPr>
@@ -1827,7 +1827,7 @@
           <p:cNvPr id="3" name="Notes Placeholder 2">
             <a:extLst>
               <a:ext uri="{FF2B5EF4-FFF2-40B4-BE49-F238E27FC236}">
-                <a16:creationId xmlns="" xmlns:a16="http://schemas.microsoft.com/office/drawing/2014/main" id="{3AC76129-7A35-2EDC-3B76-87ED8A84114D}"/>
+                <a16:creationId xmlns:a16="http://schemas.microsoft.com/office/drawing/2014/main" xmlns="" id="{3AC76129-7A35-2EDC-3B76-87ED8A84114D}"/>
               </a:ext>
             </a:extLst>
           </p:cNvPr>
@@ -1852,7 +1852,7 @@
           <p:cNvPr id="4" name="Slide Number Placeholder 3">
             <a:extLst>
               <a:ext uri="{FF2B5EF4-FFF2-40B4-BE49-F238E27FC236}">
-                <a16:creationId xmlns="" xmlns:a16="http://schemas.microsoft.com/office/drawing/2014/main" id="{2BF5D66A-BD02-F7EA-3FAB-C98B27E37E51}"/>
+                <a16:creationId xmlns:a16="http://schemas.microsoft.com/office/drawing/2014/main" xmlns="" id="{2BF5D66A-BD02-F7EA-3FAB-C98B27E37E51}"/>
               </a:ext>
             </a:extLst>
           </p:cNvPr>
@@ -5014,7 +5014,7 @@
           <p:cNvPr id="2" name="Title 1">
             <a:extLst>
               <a:ext uri="{FF2B5EF4-FFF2-40B4-BE49-F238E27FC236}">
-                <a16:creationId xmlns="" xmlns:a16="http://schemas.microsoft.com/office/drawing/2014/main" id="{0AFE4333-EDCB-768D-D694-4FA374C887CA}"/>
+                <a16:creationId xmlns:a16="http://schemas.microsoft.com/office/drawing/2014/main" xmlns="" id="{0AFE4333-EDCB-768D-D694-4FA374C887CA}"/>
               </a:ext>
             </a:extLst>
           </p:cNvPr>
@@ -5052,7 +5052,7 @@
           <p:cNvPr id="3" name="Subtitle 2">
             <a:extLst>
               <a:ext uri="{FF2B5EF4-FFF2-40B4-BE49-F238E27FC236}">
-                <a16:creationId xmlns="" xmlns:a16="http://schemas.microsoft.com/office/drawing/2014/main" id="{6FB8F6BA-A771-5199-B454-4137B42B826B}"/>
+                <a16:creationId xmlns:a16="http://schemas.microsoft.com/office/drawing/2014/main" xmlns="" id="{6FB8F6BA-A771-5199-B454-4137B42B826B}"/>
               </a:ext>
             </a:extLst>
           </p:cNvPr>
@@ -5123,7 +5123,7 @@
           <p:cNvPr id="4" name="Date Placeholder 3">
             <a:extLst>
               <a:ext uri="{FF2B5EF4-FFF2-40B4-BE49-F238E27FC236}">
-                <a16:creationId xmlns="" xmlns:a16="http://schemas.microsoft.com/office/drawing/2014/main" id="{AB8C62A8-5E14-FA7C-D2D9-A91C5617AEE2}"/>
+                <a16:creationId xmlns:a16="http://schemas.microsoft.com/office/drawing/2014/main" xmlns="" id="{AB8C62A8-5E14-FA7C-D2D9-A91C5617AEE2}"/>
               </a:ext>
             </a:extLst>
           </p:cNvPr>
@@ -5141,7 +5141,7 @@
           <a:p>
             <a:fld id="{617C7221-54BD-4A63-8AE7-749436A8A0E0}" type="datetime1">
               <a:rPr lang="en-US" smtClean="0"/>
-              <a:t>2/24/2026</a:t>
+              <a:t>4/7/2026</a:t>
             </a:fld>
             <a:endParaRPr lang="en-US" dirty="0"/>
           </a:p>
@@ -5152,7 +5152,7 @@
           <p:cNvPr id="5" name="Footer Placeholder 4">
             <a:extLst>
               <a:ext uri="{FF2B5EF4-FFF2-40B4-BE49-F238E27FC236}">
-                <a16:creationId xmlns="" xmlns:a16="http://schemas.microsoft.com/office/drawing/2014/main" id="{EA5CADB1-111D-22D3-EDB1-E043DC323ABF}"/>
+                <a16:creationId xmlns:a16="http://schemas.microsoft.com/office/drawing/2014/main" xmlns="" id="{EA5CADB1-111D-22D3-EDB1-E043DC323ABF}"/>
               </a:ext>
             </a:extLst>
           </p:cNvPr>
@@ -5180,7 +5180,7 @@
           <p:cNvPr id="6" name="Slide Number Placeholder 5">
             <a:extLst>
               <a:ext uri="{FF2B5EF4-FFF2-40B4-BE49-F238E27FC236}">
-                <a16:creationId xmlns="" xmlns:a16="http://schemas.microsoft.com/office/drawing/2014/main" id="{D733105E-4498-96A3-0C5F-A5E579283B92}"/>
+                <a16:creationId xmlns:a16="http://schemas.microsoft.com/office/drawing/2014/main" xmlns="" id="{D733105E-4498-96A3-0C5F-A5E579283B92}"/>
               </a:ext>
             </a:extLst>
           </p:cNvPr>
@@ -5239,7 +5239,7 @@
           <p:cNvPr id="2" name="Title 1">
             <a:extLst>
               <a:ext uri="{FF2B5EF4-FFF2-40B4-BE49-F238E27FC236}">
-                <a16:creationId xmlns="" xmlns:a16="http://schemas.microsoft.com/office/drawing/2014/main" id="{CAE933A4-C03D-26A7-C451-392D04E6A237}"/>
+                <a16:creationId xmlns:a16="http://schemas.microsoft.com/office/drawing/2014/main" xmlns="" id="{CAE933A4-C03D-26A7-C451-392D04E6A237}"/>
               </a:ext>
             </a:extLst>
           </p:cNvPr>
@@ -5268,7 +5268,7 @@
           <p:cNvPr id="3" name="Vertical Text Placeholder 2">
             <a:extLst>
               <a:ext uri="{FF2B5EF4-FFF2-40B4-BE49-F238E27FC236}">
-                <a16:creationId xmlns="" xmlns:a16="http://schemas.microsoft.com/office/drawing/2014/main" id="{C339E290-0E60-50DC-3A6D-AFC921C4E839}"/>
+                <a16:creationId xmlns:a16="http://schemas.microsoft.com/office/drawing/2014/main" xmlns="" id="{C339E290-0E60-50DC-3A6D-AFC921C4E839}"/>
               </a:ext>
             </a:extLst>
           </p:cNvPr>
@@ -5326,7 +5326,7 @@
           <p:cNvPr id="4" name="Date Placeholder 3">
             <a:extLst>
               <a:ext uri="{FF2B5EF4-FFF2-40B4-BE49-F238E27FC236}">
-                <a16:creationId xmlns="" xmlns:a16="http://schemas.microsoft.com/office/drawing/2014/main" id="{B1DDBB31-5065-A920-BCE3-A6379F318E85}"/>
+                <a16:creationId xmlns:a16="http://schemas.microsoft.com/office/drawing/2014/main" xmlns="" id="{B1DDBB31-5065-A920-BCE3-A6379F318E85}"/>
               </a:ext>
             </a:extLst>
           </p:cNvPr>
@@ -5344,7 +5344,7 @@
           <a:p>
             <a:fld id="{159EA562-091E-45D6-BEDF-3C68FB2023F1}" type="datetime1">
               <a:rPr lang="en-US" smtClean="0"/>
-              <a:t>2/24/2026</a:t>
+              <a:t>4/7/2026</a:t>
             </a:fld>
             <a:endParaRPr lang="en-US" dirty="0"/>
           </a:p>
@@ -5355,7 +5355,7 @@
           <p:cNvPr id="5" name="Footer Placeholder 4">
             <a:extLst>
               <a:ext uri="{FF2B5EF4-FFF2-40B4-BE49-F238E27FC236}">
-                <a16:creationId xmlns="" xmlns:a16="http://schemas.microsoft.com/office/drawing/2014/main" id="{8650F398-CC52-3E67-DDF6-C862313CC410}"/>
+                <a16:creationId xmlns:a16="http://schemas.microsoft.com/office/drawing/2014/main" xmlns="" id="{8650F398-CC52-3E67-DDF6-C862313CC410}"/>
               </a:ext>
             </a:extLst>
           </p:cNvPr>
@@ -5383,7 +5383,7 @@
           <p:cNvPr id="6" name="Slide Number Placeholder 5">
             <a:extLst>
               <a:ext uri="{FF2B5EF4-FFF2-40B4-BE49-F238E27FC236}">
-                <a16:creationId xmlns="" xmlns:a16="http://schemas.microsoft.com/office/drawing/2014/main" id="{4272AE45-AD9E-08FA-1F71-75DFC9E00C85}"/>
+                <a16:creationId xmlns:a16="http://schemas.microsoft.com/office/drawing/2014/main" xmlns="" id="{4272AE45-AD9E-08FA-1F71-75DFC9E00C85}"/>
               </a:ext>
             </a:extLst>
           </p:cNvPr>
@@ -5442,7 +5442,7 @@
           <p:cNvPr id="2" name="Vertical Title 1">
             <a:extLst>
               <a:ext uri="{FF2B5EF4-FFF2-40B4-BE49-F238E27FC236}">
-                <a16:creationId xmlns="" xmlns:a16="http://schemas.microsoft.com/office/drawing/2014/main" id="{0AF91D67-8C5B-5055-B5D2-6BAAE7E95038}"/>
+                <a16:creationId xmlns:a16="http://schemas.microsoft.com/office/drawing/2014/main" xmlns="" id="{0AF91D67-8C5B-5055-B5D2-6BAAE7E95038}"/>
               </a:ext>
             </a:extLst>
           </p:cNvPr>
@@ -5476,7 +5476,7 @@
           <p:cNvPr id="3" name="Vertical Text Placeholder 2">
             <a:extLst>
               <a:ext uri="{FF2B5EF4-FFF2-40B4-BE49-F238E27FC236}">
-                <a16:creationId xmlns="" xmlns:a16="http://schemas.microsoft.com/office/drawing/2014/main" id="{04D31080-7646-1B9C-C36F-D2F6BB874738}"/>
+                <a16:creationId xmlns:a16="http://schemas.microsoft.com/office/drawing/2014/main" xmlns="" id="{04D31080-7646-1B9C-C36F-D2F6BB874738}"/>
               </a:ext>
             </a:extLst>
           </p:cNvPr>
@@ -5539,7 +5539,7 @@
           <p:cNvPr id="4" name="Date Placeholder 3">
             <a:extLst>
               <a:ext uri="{FF2B5EF4-FFF2-40B4-BE49-F238E27FC236}">
-                <a16:creationId xmlns="" xmlns:a16="http://schemas.microsoft.com/office/drawing/2014/main" id="{BDA404C4-6EA5-D815-E9B2-7CDBB94E9D0D}"/>
+                <a16:creationId xmlns:a16="http://schemas.microsoft.com/office/drawing/2014/main" xmlns="" id="{BDA404C4-6EA5-D815-E9B2-7CDBB94E9D0D}"/>
               </a:ext>
             </a:extLst>
           </p:cNvPr>
@@ -5557,7 +5557,7 @@
           <a:p>
             <a:fld id="{DDF14D94-52B8-43E9-A8F3-BD9E24437DA3}" type="datetime1">
               <a:rPr lang="en-US" smtClean="0"/>
-              <a:t>2/24/2026</a:t>
+              <a:t>4/7/2026</a:t>
             </a:fld>
             <a:endParaRPr lang="en-US" dirty="0"/>
           </a:p>
@@ -5568,7 +5568,7 @@
           <p:cNvPr id="5" name="Footer Placeholder 4">
             <a:extLst>
               <a:ext uri="{FF2B5EF4-FFF2-40B4-BE49-F238E27FC236}">
-                <a16:creationId xmlns="" xmlns:a16="http://schemas.microsoft.com/office/drawing/2014/main" id="{97EFDD0D-44E3-A86F-6F17-A722DA9F5AB5}"/>
+                <a16:creationId xmlns:a16="http://schemas.microsoft.com/office/drawing/2014/main" xmlns="" id="{97EFDD0D-44E3-A86F-6F17-A722DA9F5AB5}"/>
               </a:ext>
             </a:extLst>
           </p:cNvPr>
@@ -5596,7 +5596,7 @@
           <p:cNvPr id="6" name="Slide Number Placeholder 5">
             <a:extLst>
               <a:ext uri="{FF2B5EF4-FFF2-40B4-BE49-F238E27FC236}">
-                <a16:creationId xmlns="" xmlns:a16="http://schemas.microsoft.com/office/drawing/2014/main" id="{83E417A5-F8F0-AA31-71DF-34D6584981BA}"/>
+                <a16:creationId xmlns:a16="http://schemas.microsoft.com/office/drawing/2014/main" xmlns="" id="{83E417A5-F8F0-AA31-71DF-34D6584981BA}"/>
               </a:ext>
             </a:extLst>
           </p:cNvPr>
@@ -5655,7 +5655,7 @@
           <p:cNvPr id="2" name="Title 1">
             <a:extLst>
               <a:ext uri="{FF2B5EF4-FFF2-40B4-BE49-F238E27FC236}">
-                <a16:creationId xmlns="" xmlns:a16="http://schemas.microsoft.com/office/drawing/2014/main" id="{7EAE6418-E00D-D82B-5A6A-A2532DB41F10}"/>
+                <a16:creationId xmlns:a16="http://schemas.microsoft.com/office/drawing/2014/main" xmlns="" id="{7EAE6418-E00D-D82B-5A6A-A2532DB41F10}"/>
               </a:ext>
             </a:extLst>
           </p:cNvPr>
@@ -5684,7 +5684,7 @@
           <p:cNvPr id="3" name="Content Placeholder 2">
             <a:extLst>
               <a:ext uri="{FF2B5EF4-FFF2-40B4-BE49-F238E27FC236}">
-                <a16:creationId xmlns="" xmlns:a16="http://schemas.microsoft.com/office/drawing/2014/main" id="{F63E6B97-B778-7455-F70C-FD8D34E3F3DF}"/>
+                <a16:creationId xmlns:a16="http://schemas.microsoft.com/office/drawing/2014/main" xmlns="" id="{F63E6B97-B778-7455-F70C-FD8D34E3F3DF}"/>
               </a:ext>
             </a:extLst>
           </p:cNvPr>
@@ -5742,7 +5742,7 @@
           <p:cNvPr id="4" name="Date Placeholder 3">
             <a:extLst>
               <a:ext uri="{FF2B5EF4-FFF2-40B4-BE49-F238E27FC236}">
-                <a16:creationId xmlns="" xmlns:a16="http://schemas.microsoft.com/office/drawing/2014/main" id="{34537FB2-C318-A7C1-BABA-0AC6FA5B35AC}"/>
+                <a16:creationId xmlns:a16="http://schemas.microsoft.com/office/drawing/2014/main" xmlns="" id="{34537FB2-C318-A7C1-BABA-0AC6FA5B35AC}"/>
               </a:ext>
             </a:extLst>
           </p:cNvPr>
@@ -5760,7 +5760,7 @@
           <a:p>
             <a:fld id="{15296570-B1EA-4487-BE32-F708B8E167B2}" type="datetime1">
               <a:rPr lang="en-US" smtClean="0"/>
-              <a:t>2/24/2026</a:t>
+              <a:t>4/7/2026</a:t>
             </a:fld>
             <a:endParaRPr lang="en-US" dirty="0"/>
           </a:p>
@@ -5771,7 +5771,7 @@
           <p:cNvPr id="5" name="Footer Placeholder 4">
             <a:extLst>
               <a:ext uri="{FF2B5EF4-FFF2-40B4-BE49-F238E27FC236}">
-                <a16:creationId xmlns="" xmlns:a16="http://schemas.microsoft.com/office/drawing/2014/main" id="{914FC2A1-527D-0AA9-D04D-3D2766CE0E10}"/>
+                <a16:creationId xmlns:a16="http://schemas.microsoft.com/office/drawing/2014/main" xmlns="" id="{914FC2A1-527D-0AA9-D04D-3D2766CE0E10}"/>
               </a:ext>
             </a:extLst>
           </p:cNvPr>
@@ -5799,7 +5799,7 @@
           <p:cNvPr id="6" name="Slide Number Placeholder 5">
             <a:extLst>
               <a:ext uri="{FF2B5EF4-FFF2-40B4-BE49-F238E27FC236}">
-                <a16:creationId xmlns="" xmlns:a16="http://schemas.microsoft.com/office/drawing/2014/main" id="{81000CB2-5293-8DFA-B3B2-A0B592B46511}"/>
+                <a16:creationId xmlns:a16="http://schemas.microsoft.com/office/drawing/2014/main" xmlns="" id="{81000CB2-5293-8DFA-B3B2-A0B592B46511}"/>
               </a:ext>
             </a:extLst>
           </p:cNvPr>
@@ -5858,7 +5858,7 @@
           <p:cNvPr id="2" name="Title 1">
             <a:extLst>
               <a:ext uri="{FF2B5EF4-FFF2-40B4-BE49-F238E27FC236}">
-                <a16:creationId xmlns="" xmlns:a16="http://schemas.microsoft.com/office/drawing/2014/main" id="{AEC1FA87-C082-E0DD-3D37-67F1640E6768}"/>
+                <a16:creationId xmlns:a16="http://schemas.microsoft.com/office/drawing/2014/main" xmlns="" id="{AEC1FA87-C082-E0DD-3D37-67F1640E6768}"/>
               </a:ext>
             </a:extLst>
           </p:cNvPr>
@@ -5896,7 +5896,7 @@
           <p:cNvPr id="3" name="Text Placeholder 2">
             <a:extLst>
               <a:ext uri="{FF2B5EF4-FFF2-40B4-BE49-F238E27FC236}">
-                <a16:creationId xmlns="" xmlns:a16="http://schemas.microsoft.com/office/drawing/2014/main" id="{1B5F515E-EB4A-D143-3D90-D5CB688823BA}"/>
+                <a16:creationId xmlns:a16="http://schemas.microsoft.com/office/drawing/2014/main" xmlns="" id="{1B5F515E-EB4A-D143-3D90-D5CB688823BA}"/>
               </a:ext>
             </a:extLst>
           </p:cNvPr>
@@ -6021,7 +6021,7 @@
           <p:cNvPr id="4" name="Date Placeholder 3">
             <a:extLst>
               <a:ext uri="{FF2B5EF4-FFF2-40B4-BE49-F238E27FC236}">
-                <a16:creationId xmlns="" xmlns:a16="http://schemas.microsoft.com/office/drawing/2014/main" id="{88B15D29-75FB-CFE9-A973-A208274B95BA}"/>
+                <a16:creationId xmlns:a16="http://schemas.microsoft.com/office/drawing/2014/main" xmlns="" id="{88B15D29-75FB-CFE9-A973-A208274B95BA}"/>
               </a:ext>
             </a:extLst>
           </p:cNvPr>
@@ -6039,7 +6039,7 @@
           <a:p>
             <a:fld id="{4F9442CB-DE38-41A3-9AEC-FC7F477AE398}" type="datetime1">
               <a:rPr lang="en-US" smtClean="0"/>
-              <a:t>2/24/2026</a:t>
+              <a:t>4/7/2026</a:t>
             </a:fld>
             <a:endParaRPr lang="en-US" dirty="0"/>
           </a:p>
@@ -6050,7 +6050,7 @@
           <p:cNvPr id="5" name="Footer Placeholder 4">
             <a:extLst>
               <a:ext uri="{FF2B5EF4-FFF2-40B4-BE49-F238E27FC236}">
-                <a16:creationId xmlns="" xmlns:a16="http://schemas.microsoft.com/office/drawing/2014/main" id="{E9168659-4604-1E12-A046-E65E9BFA0D3E}"/>
+                <a16:creationId xmlns:a16="http://schemas.microsoft.com/office/drawing/2014/main" xmlns="" id="{E9168659-4604-1E12-A046-E65E9BFA0D3E}"/>
               </a:ext>
             </a:extLst>
           </p:cNvPr>
@@ -6078,7 +6078,7 @@
           <p:cNvPr id="6" name="Slide Number Placeholder 5">
             <a:extLst>
               <a:ext uri="{FF2B5EF4-FFF2-40B4-BE49-F238E27FC236}">
-                <a16:creationId xmlns="" xmlns:a16="http://schemas.microsoft.com/office/drawing/2014/main" id="{86A55C1A-5CB6-A517-F4CC-78B642B353A1}"/>
+                <a16:creationId xmlns:a16="http://schemas.microsoft.com/office/drawing/2014/main" xmlns="" id="{86A55C1A-5CB6-A517-F4CC-78B642B353A1}"/>
               </a:ext>
             </a:extLst>
           </p:cNvPr>
@@ -6137,7 +6137,7 @@
           <p:cNvPr id="2" name="Title 1">
             <a:extLst>
               <a:ext uri="{FF2B5EF4-FFF2-40B4-BE49-F238E27FC236}">
-                <a16:creationId xmlns="" xmlns:a16="http://schemas.microsoft.com/office/drawing/2014/main" id="{5F354BD7-8381-6AF7-2A34-97F116432198}"/>
+                <a16:creationId xmlns:a16="http://schemas.microsoft.com/office/drawing/2014/main" xmlns="" id="{5F354BD7-8381-6AF7-2A34-97F116432198}"/>
               </a:ext>
             </a:extLst>
           </p:cNvPr>
@@ -6166,7 +6166,7 @@
           <p:cNvPr id="3" name="Content Placeholder 2">
             <a:extLst>
               <a:ext uri="{FF2B5EF4-FFF2-40B4-BE49-F238E27FC236}">
-                <a16:creationId xmlns="" xmlns:a16="http://schemas.microsoft.com/office/drawing/2014/main" id="{745D5CF0-745C-8F39-DDFC-095163A6D86D}"/>
+                <a16:creationId xmlns:a16="http://schemas.microsoft.com/office/drawing/2014/main" xmlns="" id="{745D5CF0-745C-8F39-DDFC-095163A6D86D}"/>
               </a:ext>
             </a:extLst>
           </p:cNvPr>
@@ -6229,7 +6229,7 @@
           <p:cNvPr id="4" name="Content Placeholder 3">
             <a:extLst>
               <a:ext uri="{FF2B5EF4-FFF2-40B4-BE49-F238E27FC236}">
-                <a16:creationId xmlns="" xmlns:a16="http://schemas.microsoft.com/office/drawing/2014/main" id="{D6F0486A-0B81-6F67-77F7-3933C2505882}"/>
+                <a16:creationId xmlns:a16="http://schemas.microsoft.com/office/drawing/2014/main" xmlns="" id="{D6F0486A-0B81-6F67-77F7-3933C2505882}"/>
               </a:ext>
             </a:extLst>
           </p:cNvPr>
@@ -6292,7 +6292,7 @@
           <p:cNvPr id="5" name="Date Placeholder 4">
             <a:extLst>
               <a:ext uri="{FF2B5EF4-FFF2-40B4-BE49-F238E27FC236}">
-                <a16:creationId xmlns="" xmlns:a16="http://schemas.microsoft.com/office/drawing/2014/main" id="{D29CEC8B-FF84-E5F1-CD4B-B7DEE25F0DBA}"/>
+                <a16:creationId xmlns:a16="http://schemas.microsoft.com/office/drawing/2014/main" xmlns="" id="{D29CEC8B-FF84-E5F1-CD4B-B7DEE25F0DBA}"/>
               </a:ext>
             </a:extLst>
           </p:cNvPr>
@@ -6310,7 +6310,7 @@
           <a:p>
             <a:fld id="{4259B145-4D2C-4B0D-B0F3-3793104D85F9}" type="datetime1">
               <a:rPr lang="en-US" smtClean="0"/>
-              <a:t>2/24/2026</a:t>
+              <a:t>4/7/2026</a:t>
             </a:fld>
             <a:endParaRPr lang="en-US" dirty="0"/>
           </a:p>
@@ -6321,7 +6321,7 @@
           <p:cNvPr id="6" name="Footer Placeholder 5">
             <a:extLst>
               <a:ext uri="{FF2B5EF4-FFF2-40B4-BE49-F238E27FC236}">
-                <a16:creationId xmlns="" xmlns:a16="http://schemas.microsoft.com/office/drawing/2014/main" id="{083D1157-B890-E7C2-8551-9CFA55DF17F2}"/>
+                <a16:creationId xmlns:a16="http://schemas.microsoft.com/office/drawing/2014/main" xmlns="" id="{083D1157-B890-E7C2-8551-9CFA55DF17F2}"/>
               </a:ext>
             </a:extLst>
           </p:cNvPr>
@@ -6349,7 +6349,7 @@
           <p:cNvPr id="7" name="Slide Number Placeholder 6">
             <a:extLst>
               <a:ext uri="{FF2B5EF4-FFF2-40B4-BE49-F238E27FC236}">
-                <a16:creationId xmlns="" xmlns:a16="http://schemas.microsoft.com/office/drawing/2014/main" id="{A6834098-4893-052D-13DF-57AA3726911C}"/>
+                <a16:creationId xmlns:a16="http://schemas.microsoft.com/office/drawing/2014/main" xmlns="" id="{A6834098-4893-052D-13DF-57AA3726911C}"/>
               </a:ext>
             </a:extLst>
           </p:cNvPr>
@@ -6408,7 +6408,7 @@
           <p:cNvPr id="2" name="Title 1">
             <a:extLst>
               <a:ext uri="{FF2B5EF4-FFF2-40B4-BE49-F238E27FC236}">
-                <a16:creationId xmlns="" xmlns:a16="http://schemas.microsoft.com/office/drawing/2014/main" id="{A195ED4B-5B6D-B5E5-67B7-D97BFC6B16D2}"/>
+                <a16:creationId xmlns:a16="http://schemas.microsoft.com/office/drawing/2014/main" xmlns="" id="{A195ED4B-5B6D-B5E5-67B7-D97BFC6B16D2}"/>
               </a:ext>
             </a:extLst>
           </p:cNvPr>
@@ -6442,7 +6442,7 @@
           <p:cNvPr id="3" name="Text Placeholder 2">
             <a:extLst>
               <a:ext uri="{FF2B5EF4-FFF2-40B4-BE49-F238E27FC236}">
-                <a16:creationId xmlns="" xmlns:a16="http://schemas.microsoft.com/office/drawing/2014/main" id="{28083AD3-D8DD-C9C8-4A8D-6E90DEEDCC52}"/>
+                <a16:creationId xmlns:a16="http://schemas.microsoft.com/office/drawing/2014/main" xmlns="" id="{28083AD3-D8DD-C9C8-4A8D-6E90DEEDCC52}"/>
               </a:ext>
             </a:extLst>
           </p:cNvPr>
@@ -6513,7 +6513,7 @@
           <p:cNvPr id="4" name="Content Placeholder 3">
             <a:extLst>
               <a:ext uri="{FF2B5EF4-FFF2-40B4-BE49-F238E27FC236}">
-                <a16:creationId xmlns="" xmlns:a16="http://schemas.microsoft.com/office/drawing/2014/main" id="{F610F8FC-1E86-8328-5873-1F1FD4540F26}"/>
+                <a16:creationId xmlns:a16="http://schemas.microsoft.com/office/drawing/2014/main" xmlns="" id="{F610F8FC-1E86-8328-5873-1F1FD4540F26}"/>
               </a:ext>
             </a:extLst>
           </p:cNvPr>
@@ -6576,7 +6576,7 @@
           <p:cNvPr id="5" name="Text Placeholder 4">
             <a:extLst>
               <a:ext uri="{FF2B5EF4-FFF2-40B4-BE49-F238E27FC236}">
-                <a16:creationId xmlns="" xmlns:a16="http://schemas.microsoft.com/office/drawing/2014/main" id="{7171E56A-9B29-8C99-0F9B-DFA73577B4C9}"/>
+                <a16:creationId xmlns:a16="http://schemas.microsoft.com/office/drawing/2014/main" xmlns="" id="{7171E56A-9B29-8C99-0F9B-DFA73577B4C9}"/>
               </a:ext>
             </a:extLst>
           </p:cNvPr>
@@ -6647,7 +6647,7 @@
           <p:cNvPr id="6" name="Content Placeholder 5">
             <a:extLst>
               <a:ext uri="{FF2B5EF4-FFF2-40B4-BE49-F238E27FC236}">
-                <a16:creationId xmlns="" xmlns:a16="http://schemas.microsoft.com/office/drawing/2014/main" id="{31551D20-42E2-AA82-6A29-ED75844F6FA3}"/>
+                <a16:creationId xmlns:a16="http://schemas.microsoft.com/office/drawing/2014/main" xmlns="" id="{31551D20-42E2-AA82-6A29-ED75844F6FA3}"/>
               </a:ext>
             </a:extLst>
           </p:cNvPr>
@@ -6710,7 +6710,7 @@
           <p:cNvPr id="7" name="Date Placeholder 6">
             <a:extLst>
               <a:ext uri="{FF2B5EF4-FFF2-40B4-BE49-F238E27FC236}">
-                <a16:creationId xmlns="" xmlns:a16="http://schemas.microsoft.com/office/drawing/2014/main" id="{12806B38-A61F-CFF2-455E-2A0DB1CBD281}"/>
+                <a16:creationId xmlns:a16="http://schemas.microsoft.com/office/drawing/2014/main" xmlns="" id="{12806B38-A61F-CFF2-455E-2A0DB1CBD281}"/>
               </a:ext>
             </a:extLst>
           </p:cNvPr>
@@ -6728,7 +6728,7 @@
           <a:p>
             <a:fld id="{041CBCE3-C8C5-4329-ADE4-5F8D67D78882}" type="datetime1">
               <a:rPr lang="en-US" smtClean="0"/>
-              <a:t>2/24/2026</a:t>
+              <a:t>4/7/2026</a:t>
             </a:fld>
             <a:endParaRPr lang="en-US" dirty="0"/>
           </a:p>
@@ -6739,7 +6739,7 @@
           <p:cNvPr id="8" name="Footer Placeholder 7">
             <a:extLst>
               <a:ext uri="{FF2B5EF4-FFF2-40B4-BE49-F238E27FC236}">
-                <a16:creationId xmlns="" xmlns:a16="http://schemas.microsoft.com/office/drawing/2014/main" id="{0A1ADB39-BBED-F460-3284-9B01BBA78120}"/>
+                <a16:creationId xmlns:a16="http://schemas.microsoft.com/office/drawing/2014/main" xmlns="" id="{0A1ADB39-BBED-F460-3284-9B01BBA78120}"/>
               </a:ext>
             </a:extLst>
           </p:cNvPr>
@@ -6767,7 +6767,7 @@
           <p:cNvPr id="9" name="Slide Number Placeholder 8">
             <a:extLst>
               <a:ext uri="{FF2B5EF4-FFF2-40B4-BE49-F238E27FC236}">
-                <a16:creationId xmlns="" xmlns:a16="http://schemas.microsoft.com/office/drawing/2014/main" id="{BAE78CB4-F5B2-2F08-FCB4-B7EFC7D9B5DD}"/>
+                <a16:creationId xmlns:a16="http://schemas.microsoft.com/office/drawing/2014/main" xmlns="" id="{BAE78CB4-F5B2-2F08-FCB4-B7EFC7D9B5DD}"/>
               </a:ext>
             </a:extLst>
           </p:cNvPr>
@@ -6826,7 +6826,7 @@
           <p:cNvPr id="2" name="Title 1">
             <a:extLst>
               <a:ext uri="{FF2B5EF4-FFF2-40B4-BE49-F238E27FC236}">
-                <a16:creationId xmlns="" xmlns:a16="http://schemas.microsoft.com/office/drawing/2014/main" id="{6207DB33-3161-3CA7-5DA9-9AEFA7BE3D99}"/>
+                <a16:creationId xmlns:a16="http://schemas.microsoft.com/office/drawing/2014/main" xmlns="" id="{6207DB33-3161-3CA7-5DA9-9AEFA7BE3D99}"/>
               </a:ext>
             </a:extLst>
           </p:cNvPr>
@@ -6855,7 +6855,7 @@
           <p:cNvPr id="3" name="Date Placeholder 2">
             <a:extLst>
               <a:ext uri="{FF2B5EF4-FFF2-40B4-BE49-F238E27FC236}">
-                <a16:creationId xmlns="" xmlns:a16="http://schemas.microsoft.com/office/drawing/2014/main" id="{1B459199-60FE-8A27-4D17-58FA57F038D5}"/>
+                <a16:creationId xmlns:a16="http://schemas.microsoft.com/office/drawing/2014/main" xmlns="" id="{1B459199-60FE-8A27-4D17-58FA57F038D5}"/>
               </a:ext>
             </a:extLst>
           </p:cNvPr>
@@ -6873,7 +6873,7 @@
           <a:p>
             <a:fld id="{EA95BDD6-391D-4D68-9A24-8E7CE46A4DC4}" type="datetime1">
               <a:rPr lang="en-US" smtClean="0"/>
-              <a:t>2/24/2026</a:t>
+              <a:t>4/7/2026</a:t>
             </a:fld>
             <a:endParaRPr lang="en-US" dirty="0"/>
           </a:p>
@@ -6884,7 +6884,7 @@
           <p:cNvPr id="4" name="Footer Placeholder 3">
             <a:extLst>
               <a:ext uri="{FF2B5EF4-FFF2-40B4-BE49-F238E27FC236}">
-                <a16:creationId xmlns="" xmlns:a16="http://schemas.microsoft.com/office/drawing/2014/main" id="{9B5772E0-839B-C3B1-7E64-0C8677352A57}"/>
+                <a16:creationId xmlns:a16="http://schemas.microsoft.com/office/drawing/2014/main" xmlns="" id="{9B5772E0-839B-C3B1-7E64-0C8677352A57}"/>
               </a:ext>
             </a:extLst>
           </p:cNvPr>
@@ -6912,7 +6912,7 @@
           <p:cNvPr id="5" name="Slide Number Placeholder 4">
             <a:extLst>
               <a:ext uri="{FF2B5EF4-FFF2-40B4-BE49-F238E27FC236}">
-                <a16:creationId xmlns="" xmlns:a16="http://schemas.microsoft.com/office/drawing/2014/main" id="{4F5A1759-598D-988C-8124-2E5044B1744E}"/>
+                <a16:creationId xmlns:a16="http://schemas.microsoft.com/office/drawing/2014/main" xmlns="" id="{4F5A1759-598D-988C-8124-2E5044B1744E}"/>
               </a:ext>
             </a:extLst>
           </p:cNvPr>
@@ -6971,7 +6971,7 @@
           <p:cNvPr id="2" name="Date Placeholder 1">
             <a:extLst>
               <a:ext uri="{FF2B5EF4-FFF2-40B4-BE49-F238E27FC236}">
-                <a16:creationId xmlns="" xmlns:a16="http://schemas.microsoft.com/office/drawing/2014/main" id="{F271F3F0-F2B3-F675-7BAB-1AD2134ACD0F}"/>
+                <a16:creationId xmlns:a16="http://schemas.microsoft.com/office/drawing/2014/main" xmlns="" id="{F271F3F0-F2B3-F675-7BAB-1AD2134ACD0F}"/>
               </a:ext>
             </a:extLst>
           </p:cNvPr>
@@ -6989,7 +6989,7 @@
           <a:p>
             <a:fld id="{1B3E1E7A-3F60-43E8-97A9-E03FDFF3291A}" type="datetime1">
               <a:rPr lang="en-US" smtClean="0"/>
-              <a:t>2/24/2026</a:t>
+              <a:t>4/7/2026</a:t>
             </a:fld>
             <a:endParaRPr lang="en-US" dirty="0"/>
           </a:p>
@@ -7000,7 +7000,7 @@
           <p:cNvPr id="3" name="Footer Placeholder 2">
             <a:extLst>
               <a:ext uri="{FF2B5EF4-FFF2-40B4-BE49-F238E27FC236}">
-                <a16:creationId xmlns="" xmlns:a16="http://schemas.microsoft.com/office/drawing/2014/main" id="{1A44FB0A-DFB7-0737-F37C-440DCA486D73}"/>
+                <a16:creationId xmlns:a16="http://schemas.microsoft.com/office/drawing/2014/main" xmlns="" id="{1A44FB0A-DFB7-0737-F37C-440DCA486D73}"/>
               </a:ext>
             </a:extLst>
           </p:cNvPr>
@@ -7028,7 +7028,7 @@
           <p:cNvPr id="4" name="Slide Number Placeholder 3">
             <a:extLst>
               <a:ext uri="{FF2B5EF4-FFF2-40B4-BE49-F238E27FC236}">
-                <a16:creationId xmlns="" xmlns:a16="http://schemas.microsoft.com/office/drawing/2014/main" id="{9E497C01-947E-5E24-DB3F-90342EF0A210}"/>
+                <a16:creationId xmlns:a16="http://schemas.microsoft.com/office/drawing/2014/main" xmlns="" id="{9E497C01-947E-5E24-DB3F-90342EF0A210}"/>
               </a:ext>
             </a:extLst>
           </p:cNvPr>
@@ -7087,7 +7087,7 @@
           <p:cNvPr id="2" name="Title 1">
             <a:extLst>
               <a:ext uri="{FF2B5EF4-FFF2-40B4-BE49-F238E27FC236}">
-                <a16:creationId xmlns="" xmlns:a16="http://schemas.microsoft.com/office/drawing/2014/main" id="{78F41832-2691-E74A-0F3A-2DE9A6E44D84}"/>
+                <a16:creationId xmlns:a16="http://schemas.microsoft.com/office/drawing/2014/main" xmlns="" id="{78F41832-2691-E74A-0F3A-2DE9A6E44D84}"/>
               </a:ext>
             </a:extLst>
           </p:cNvPr>
@@ -7125,7 +7125,7 @@
           <p:cNvPr id="3" name="Content Placeholder 2">
             <a:extLst>
               <a:ext uri="{FF2B5EF4-FFF2-40B4-BE49-F238E27FC236}">
-                <a16:creationId xmlns="" xmlns:a16="http://schemas.microsoft.com/office/drawing/2014/main" id="{C94BD6CD-D7DC-A4E9-FD78-EA239F4F5539}"/>
+                <a16:creationId xmlns:a16="http://schemas.microsoft.com/office/drawing/2014/main" xmlns="" id="{C94BD6CD-D7DC-A4E9-FD78-EA239F4F5539}"/>
               </a:ext>
             </a:extLst>
           </p:cNvPr>
@@ -7216,7 +7216,7 @@
           <p:cNvPr id="4" name="Text Placeholder 3">
             <a:extLst>
               <a:ext uri="{FF2B5EF4-FFF2-40B4-BE49-F238E27FC236}">
-                <a16:creationId xmlns="" xmlns:a16="http://schemas.microsoft.com/office/drawing/2014/main" id="{54C0C722-544A-95F1-1DAD-FAD83B66339F}"/>
+                <a16:creationId xmlns:a16="http://schemas.microsoft.com/office/drawing/2014/main" xmlns="" id="{54C0C722-544A-95F1-1DAD-FAD83B66339F}"/>
               </a:ext>
             </a:extLst>
           </p:cNvPr>
@@ -7287,7 +7287,7 @@
           <p:cNvPr id="5" name="Date Placeholder 4">
             <a:extLst>
               <a:ext uri="{FF2B5EF4-FFF2-40B4-BE49-F238E27FC236}">
-                <a16:creationId xmlns="" xmlns:a16="http://schemas.microsoft.com/office/drawing/2014/main" id="{215BCDEF-8A4D-1FA5-888F-D5A3A2CEE9D4}"/>
+                <a16:creationId xmlns:a16="http://schemas.microsoft.com/office/drawing/2014/main" xmlns="" id="{215BCDEF-8A4D-1FA5-888F-D5A3A2CEE9D4}"/>
               </a:ext>
             </a:extLst>
           </p:cNvPr>
@@ -7305,7 +7305,7 @@
           <a:p>
             <a:fld id="{041F2EE0-C06F-41F5-AFE0-7056E3A01EDC}" type="datetime1">
               <a:rPr lang="en-US" smtClean="0"/>
-              <a:t>2/24/2026</a:t>
+              <a:t>4/7/2026</a:t>
             </a:fld>
             <a:endParaRPr lang="en-US" dirty="0"/>
           </a:p>
@@ -7316,7 +7316,7 @@
           <p:cNvPr id="6" name="Footer Placeholder 5">
             <a:extLst>
               <a:ext uri="{FF2B5EF4-FFF2-40B4-BE49-F238E27FC236}">
-                <a16:creationId xmlns="" xmlns:a16="http://schemas.microsoft.com/office/drawing/2014/main" id="{81C4BD8F-AAAC-F32F-ABC2-37A3D3BC6296}"/>
+                <a16:creationId xmlns:a16="http://schemas.microsoft.com/office/drawing/2014/main" xmlns="" id="{81C4BD8F-AAAC-F32F-ABC2-37A3D3BC6296}"/>
               </a:ext>
             </a:extLst>
           </p:cNvPr>
@@ -7344,7 +7344,7 @@
           <p:cNvPr id="7" name="Slide Number Placeholder 6">
             <a:extLst>
               <a:ext uri="{FF2B5EF4-FFF2-40B4-BE49-F238E27FC236}">
-                <a16:creationId xmlns="" xmlns:a16="http://schemas.microsoft.com/office/drawing/2014/main" id="{3DA79EF9-CB21-BEC5-2A25-591C945DD131}"/>
+                <a16:creationId xmlns:a16="http://schemas.microsoft.com/office/drawing/2014/main" xmlns="" id="{3DA79EF9-CB21-BEC5-2A25-591C945DD131}"/>
               </a:ext>
             </a:extLst>
           </p:cNvPr>
@@ -7403,7 +7403,7 @@
           <p:cNvPr id="2" name="Title 1">
             <a:extLst>
               <a:ext uri="{FF2B5EF4-FFF2-40B4-BE49-F238E27FC236}">
-                <a16:creationId xmlns="" xmlns:a16="http://schemas.microsoft.com/office/drawing/2014/main" id="{A7BACBD3-5050-C329-F415-3714918842FC}"/>
+                <a16:creationId xmlns:a16="http://schemas.microsoft.com/office/drawing/2014/main" xmlns="" id="{A7BACBD3-5050-C329-F415-3714918842FC}"/>
               </a:ext>
             </a:extLst>
           </p:cNvPr>
@@ -7441,7 +7441,7 @@
           <p:cNvPr id="3" name="Picture Placeholder 2">
             <a:extLst>
               <a:ext uri="{FF2B5EF4-FFF2-40B4-BE49-F238E27FC236}">
-                <a16:creationId xmlns="" xmlns:a16="http://schemas.microsoft.com/office/drawing/2014/main" id="{C4B2BE8C-8AFF-7B97-17DD-E10D476C8298}"/>
+                <a16:creationId xmlns:a16="http://schemas.microsoft.com/office/drawing/2014/main" xmlns="" id="{C4B2BE8C-8AFF-7B97-17DD-E10D476C8298}"/>
               </a:ext>
             </a:extLst>
           </p:cNvPr>
@@ -7508,7 +7508,7 @@
           <p:cNvPr id="4" name="Text Placeholder 3">
             <a:extLst>
               <a:ext uri="{FF2B5EF4-FFF2-40B4-BE49-F238E27FC236}">
-                <a16:creationId xmlns="" xmlns:a16="http://schemas.microsoft.com/office/drawing/2014/main" id="{B6B1A6C9-352E-F0FC-857A-200063A76EBD}"/>
+                <a16:creationId xmlns:a16="http://schemas.microsoft.com/office/drawing/2014/main" xmlns="" id="{B6B1A6C9-352E-F0FC-857A-200063A76EBD}"/>
               </a:ext>
             </a:extLst>
           </p:cNvPr>
@@ -7579,7 +7579,7 @@
           <p:cNvPr id="5" name="Date Placeholder 4">
             <a:extLst>
               <a:ext uri="{FF2B5EF4-FFF2-40B4-BE49-F238E27FC236}">
-                <a16:creationId xmlns="" xmlns:a16="http://schemas.microsoft.com/office/drawing/2014/main" id="{996AEC32-A02D-AF36-A64E-290A392B42FC}"/>
+                <a16:creationId xmlns:a16="http://schemas.microsoft.com/office/drawing/2014/main" xmlns="" id="{996AEC32-A02D-AF36-A64E-290A392B42FC}"/>
               </a:ext>
             </a:extLst>
           </p:cNvPr>
@@ -7597,7 +7597,7 @@
           <a:p>
             <a:fld id="{93A105E1-88D0-4311-A599-0C8A6973053A}" type="datetime1">
               <a:rPr lang="en-US" smtClean="0"/>
-              <a:t>2/24/2026</a:t>
+              <a:t>4/7/2026</a:t>
             </a:fld>
             <a:endParaRPr lang="en-US" dirty="0"/>
           </a:p>
@@ -7608,7 +7608,7 @@
           <p:cNvPr id="6" name="Footer Placeholder 5">
             <a:extLst>
               <a:ext uri="{FF2B5EF4-FFF2-40B4-BE49-F238E27FC236}">
-                <a16:creationId xmlns="" xmlns:a16="http://schemas.microsoft.com/office/drawing/2014/main" id="{26B0ECF5-F111-F43D-1DD0-2623EE225A1F}"/>
+                <a16:creationId xmlns:a16="http://schemas.microsoft.com/office/drawing/2014/main" xmlns="" id="{26B0ECF5-F111-F43D-1DD0-2623EE225A1F}"/>
               </a:ext>
             </a:extLst>
           </p:cNvPr>
@@ -7636,7 +7636,7 @@
           <p:cNvPr id="7" name="Slide Number Placeholder 6">
             <a:extLst>
               <a:ext uri="{FF2B5EF4-FFF2-40B4-BE49-F238E27FC236}">
-                <a16:creationId xmlns="" xmlns:a16="http://schemas.microsoft.com/office/drawing/2014/main" id="{A3ED8375-499D-DCA7-5D7B-91DD95B7F87A}"/>
+                <a16:creationId xmlns:a16="http://schemas.microsoft.com/office/drawing/2014/main" xmlns="" id="{A3ED8375-499D-DCA7-5D7B-91DD95B7F87A}"/>
               </a:ext>
             </a:extLst>
           </p:cNvPr>
@@ -7700,7 +7700,7 @@
           <p:cNvPr id="2" name="Title Placeholder 1">
             <a:extLst>
               <a:ext uri="{FF2B5EF4-FFF2-40B4-BE49-F238E27FC236}">
-                <a16:creationId xmlns="" xmlns:a16="http://schemas.microsoft.com/office/drawing/2014/main" id="{39A89A0B-DE9F-F1C6-643E-DCA32D53C317}"/>
+                <a16:creationId xmlns:a16="http://schemas.microsoft.com/office/drawing/2014/main" xmlns="" id="{39A89A0B-DE9F-F1C6-643E-DCA32D53C317}"/>
               </a:ext>
             </a:extLst>
           </p:cNvPr>
@@ -7739,7 +7739,7 @@
           <p:cNvPr id="3" name="Text Placeholder 2">
             <a:extLst>
               <a:ext uri="{FF2B5EF4-FFF2-40B4-BE49-F238E27FC236}">
-                <a16:creationId xmlns="" xmlns:a16="http://schemas.microsoft.com/office/drawing/2014/main" id="{3953DDAA-3094-DBCE-F38B-123FB91FDDD9}"/>
+                <a16:creationId xmlns:a16="http://schemas.microsoft.com/office/drawing/2014/main" xmlns="" id="{3953DDAA-3094-DBCE-F38B-123FB91FDDD9}"/>
               </a:ext>
             </a:extLst>
           </p:cNvPr>
@@ -7807,7 +7807,7 @@
           <p:cNvPr id="4" name="Date Placeholder 3">
             <a:extLst>
               <a:ext uri="{FF2B5EF4-FFF2-40B4-BE49-F238E27FC236}">
-                <a16:creationId xmlns="" xmlns:a16="http://schemas.microsoft.com/office/drawing/2014/main" id="{8AF0BF9E-5E8A-1649-84DC-281A5BAAC4CB}"/>
+                <a16:creationId xmlns:a16="http://schemas.microsoft.com/office/drawing/2014/main" xmlns="" id="{8AF0BF9E-5E8A-1649-84DC-281A5BAAC4CB}"/>
               </a:ext>
             </a:extLst>
           </p:cNvPr>
@@ -7843,7 +7843,7 @@
           <a:p>
             <a:fld id="{B6BC827E-01D8-46AF-B9E0-11E08B19BA59}" type="datetime1">
               <a:rPr lang="en-US" smtClean="0"/>
-              <a:t>2/24/2026</a:t>
+              <a:t>4/7/2026</a:t>
             </a:fld>
             <a:endParaRPr lang="en-US" dirty="0"/>
           </a:p>
@@ -7854,7 +7854,7 @@
           <p:cNvPr id="5" name="Footer Placeholder 4">
             <a:extLst>
               <a:ext uri="{FF2B5EF4-FFF2-40B4-BE49-F238E27FC236}">
-                <a16:creationId xmlns="" xmlns:a16="http://schemas.microsoft.com/office/drawing/2014/main" id="{5BDEDD1E-16D6-9C67-B90A-3F23927ED3DA}"/>
+                <a16:creationId xmlns:a16="http://schemas.microsoft.com/office/drawing/2014/main" xmlns="" id="{5BDEDD1E-16D6-9C67-B90A-3F23927ED3DA}"/>
               </a:ext>
             </a:extLst>
           </p:cNvPr>
@@ -7900,7 +7900,7 @@
           <p:cNvPr id="6" name="Slide Number Placeholder 5">
             <a:extLst>
               <a:ext uri="{FF2B5EF4-FFF2-40B4-BE49-F238E27FC236}">
-                <a16:creationId xmlns="" xmlns:a16="http://schemas.microsoft.com/office/drawing/2014/main" id="{B5FC0268-EDD9-BFDA-9A07-5241871BF476}"/>
+                <a16:creationId xmlns:a16="http://schemas.microsoft.com/office/drawing/2014/main" xmlns="" id="{B5FC0268-EDD9-BFDA-9A07-5241871BF476}"/>
               </a:ext>
             </a:extLst>
           </p:cNvPr>
@@ -8255,7 +8255,7 @@
         <p:cNvPr id="1" name="">
           <a:extLst>
             <a:ext uri="{FF2B5EF4-FFF2-40B4-BE49-F238E27FC236}">
-              <a16:creationId xmlns="" xmlns:a16="http://schemas.microsoft.com/office/drawing/2014/main" id="{9A00AC01-0D1B-4670-B29D-784BF9417E63}"/>
+              <a16:creationId xmlns:a16="http://schemas.microsoft.com/office/drawing/2014/main" xmlns="" id="{9A00AC01-0D1B-4670-B29D-784BF9417E63}"/>
             </a:ext>
           </a:extLst>
         </p:cNvPr>
@@ -8275,7 +8275,7 @@
           <p:cNvPr id="6" name="Rectangle 5">
             <a:extLst>
               <a:ext uri="{FF2B5EF4-FFF2-40B4-BE49-F238E27FC236}">
-                <a16:creationId xmlns="" xmlns:a16="http://schemas.microsoft.com/office/drawing/2014/main" id="{F42AC56F-B988-068F-5073-41D324EA661F}"/>
+                <a16:creationId xmlns:a16="http://schemas.microsoft.com/office/drawing/2014/main" xmlns="" id="{F42AC56F-B988-068F-5073-41D324EA661F}"/>
               </a:ext>
             </a:extLst>
           </p:cNvPr>
@@ -8324,7 +8324,7 @@
           <p:cNvPr id="7" name="Rectangle 6">
             <a:extLst>
               <a:ext uri="{FF2B5EF4-FFF2-40B4-BE49-F238E27FC236}">
-                <a16:creationId xmlns="" xmlns:a16="http://schemas.microsoft.com/office/drawing/2014/main" id="{1C7ED88D-99A7-E7D0-D563-319B47D0A7A8}"/>
+                <a16:creationId xmlns:a16="http://schemas.microsoft.com/office/drawing/2014/main" xmlns="" id="{1C7ED88D-99A7-E7D0-D563-319B47D0A7A8}"/>
               </a:ext>
             </a:extLst>
           </p:cNvPr>
@@ -8373,7 +8373,7 @@
           <p:cNvPr id="8" name="TextBox 7">
             <a:extLst>
               <a:ext uri="{FF2B5EF4-FFF2-40B4-BE49-F238E27FC236}">
-                <a16:creationId xmlns="" xmlns:a16="http://schemas.microsoft.com/office/drawing/2014/main" id="{86D9703F-8E7B-39E7-D187-C45F9BE29396}"/>
+                <a16:creationId xmlns:a16="http://schemas.microsoft.com/office/drawing/2014/main" xmlns="" id="{86D9703F-8E7B-39E7-D187-C45F9BE29396}"/>
               </a:ext>
             </a:extLst>
           </p:cNvPr>
@@ -8412,43 +8412,6 @@
           </a:p>
         </p:txBody>
       </p:sp>
-      <p:cxnSp>
-        <p:nvCxnSpPr>
-          <p:cNvPr id="3" name="Straight Connector 2"/>
-          <p:cNvCxnSpPr/>
-          <p:nvPr/>
-        </p:nvCxnSpPr>
-        <p:spPr>
-          <a:xfrm>
-            <a:off x="5767420" y="1369759"/>
-            <a:ext cx="13648" cy="5322277"/>
-          </a:xfrm>
-          <a:prstGeom prst="line">
-            <a:avLst/>
-          </a:prstGeom>
-          <a:ln>
-            <a:solidFill>
-              <a:schemeClr val="bg1">
-                <a:lumMod val="85000"/>
-              </a:schemeClr>
-            </a:solidFill>
-          </a:ln>
-        </p:spPr>
-        <p:style>
-          <a:lnRef idx="1">
-            <a:schemeClr val="accent1"/>
-          </a:lnRef>
-          <a:fillRef idx="0">
-            <a:schemeClr val="accent1"/>
-          </a:fillRef>
-          <a:effectRef idx="0">
-            <a:schemeClr val="accent1"/>
-          </a:effectRef>
-          <a:fontRef idx="minor">
-            <a:schemeClr val="tx1"/>
-          </a:fontRef>
-        </p:style>
-      </p:cxnSp>
       <p:cxnSp>
         <p:nvCxnSpPr>
           <p:cNvPr id="18" name="Straight Connector 17"/>
@@ -8492,7 +8455,7 @@
           <p:cNvPr id="23" name="Google Shape;143;p1">
             <a:extLst>
               <a:ext uri="{FF2B5EF4-FFF2-40B4-BE49-F238E27FC236}">
-                <a16:creationId xmlns="" xmlns:a16="http://schemas.microsoft.com/office/drawing/2014/main" id="{E4949A97-DC03-56A5-2E5A-3DD3913AA0EF}"/>
+                <a16:creationId xmlns:a16="http://schemas.microsoft.com/office/drawing/2014/main" xmlns="" id="{E4949A97-DC03-56A5-2E5A-3DD3913AA0EF}"/>
               </a:ext>
             </a:extLst>
           </p:cNvPr>
@@ -8851,7 +8814,7 @@
           <p:cNvPr id="25" name="Picture 24">
             <a:extLst>
               <a:ext uri="{FF2B5EF4-FFF2-40B4-BE49-F238E27FC236}">
-                <a16:creationId xmlns="" xmlns:a16="http://schemas.microsoft.com/office/drawing/2014/main" id="{8E4B4487-5609-54AF-1FCA-AB3F6B737AF7}"/>
+                <a16:creationId xmlns:a16="http://schemas.microsoft.com/office/drawing/2014/main" xmlns="" id="{8E4B4487-5609-54AF-1FCA-AB3F6B737AF7}"/>
               </a:ext>
             </a:extLst>
           </p:cNvPr>
@@ -9374,6 +9337,254 @@
           </p:txBody>
         </p:sp>
       </p:grpSp>
+      <p:sp>
+        <p:nvSpPr>
+          <p:cNvPr id="4" name="TextBox 3"/>
+          <p:cNvSpPr txBox="1"/>
+          <p:nvPr/>
+        </p:nvSpPr>
+        <p:spPr>
+          <a:xfrm>
+            <a:off x="6239257" y="3859260"/>
+            <a:ext cx="1699504" cy="307777"/>
+          </a:xfrm>
+          <a:prstGeom prst="rect">
+            <a:avLst/>
+          </a:prstGeom>
+          <a:solidFill>
+            <a:srgbClr val="33CC33"/>
+          </a:solidFill>
+          <a:ln>
+            <a:solidFill>
+              <a:srgbClr val="006600"/>
+            </a:solidFill>
+          </a:ln>
+          <a:effectLst/>
+        </p:spPr>
+        <p:txBody>
+          <a:bodyPr vert="horz" wrap="none" lIns="91440" tIns="45720" rIns="91440" bIns="45720" numCol="1" anchor="ctr" anchorCtr="0" compatLnSpc="1">
+            <a:prstTxWarp prst="textNoShape">
+              <a:avLst/>
+            </a:prstTxWarp>
+            <a:spAutoFit/>
+          </a:bodyPr>
+          <a:lstStyle>
+            <a:defPPr>
+              <a:defRPr lang="en-US"/>
+            </a:defPPr>
+            <a:lvl1pPr marR="0" lvl="0" indent="0" fontAlgn="base">
+              <a:lnSpc>
+                <a:spcPct val="100000"/>
+              </a:lnSpc>
+              <a:spcBef>
+                <a:spcPct val="0"/>
+              </a:spcBef>
+              <a:spcAft>
+                <a:spcPct val="0"/>
+              </a:spcAft>
+              <a:buClrTx/>
+              <a:buSzTx/>
+              <a:buFontTx/>
+              <a:buNone/>
+              <a:tabLst/>
+              <a:defRPr sz="1600">
+                <a:latin typeface="Arial Unicode MS" pitchFamily="34" charset="-128"/>
+                <a:ea typeface="Arial Unicode MS" pitchFamily="34" charset="-128"/>
+                <a:cs typeface="Arial Unicode MS" pitchFamily="34" charset="-128"/>
+              </a:defRPr>
+            </a:lvl1pPr>
+          </a:lstStyle>
+          <a:p>
+            <a:r>
+              <a:rPr lang="en-US" sz="1400" dirty="0">
+                <a:latin typeface="Bahnschrift Light" pitchFamily="34" charset="0"/>
+              </a:rPr>
+              <a:t>What is dimention?</a:t>
+            </a:r>
+            <a:endParaRPr lang="en-IN" sz="1400" dirty="0">
+              <a:latin typeface="Bahnschrift Light" pitchFamily="34" charset="0"/>
+            </a:endParaRPr>
+          </a:p>
+        </p:txBody>
+      </p:sp>
+      <p:grpSp>
+        <p:nvGrpSpPr>
+          <p:cNvPr id="15" name="Group 14"/>
+          <p:cNvGrpSpPr/>
+          <p:nvPr/>
+        </p:nvGrpSpPr>
+        <p:grpSpPr>
+          <a:xfrm>
+            <a:off x="5753772" y="1378173"/>
+            <a:ext cx="6309274" cy="5322277"/>
+            <a:chOff x="5753772" y="1378173"/>
+            <a:chExt cx="6309274" cy="5322277"/>
+          </a:xfrm>
+        </p:grpSpPr>
+        <p:cxnSp>
+          <p:nvCxnSpPr>
+            <p:cNvPr id="3" name="Straight Connector 2"/>
+            <p:cNvCxnSpPr/>
+            <p:nvPr/>
+          </p:nvCxnSpPr>
+          <p:spPr>
+            <a:xfrm>
+              <a:off x="5753772" y="1378173"/>
+              <a:ext cx="13648" cy="5322277"/>
+            </a:xfrm>
+            <a:prstGeom prst="line">
+              <a:avLst/>
+            </a:prstGeom>
+            <a:ln>
+              <a:solidFill>
+                <a:schemeClr val="bg1">
+                  <a:lumMod val="85000"/>
+                </a:schemeClr>
+              </a:solidFill>
+            </a:ln>
+          </p:spPr>
+          <p:style>
+            <a:lnRef idx="1">
+              <a:schemeClr val="accent1"/>
+            </a:lnRef>
+            <a:fillRef idx="0">
+              <a:schemeClr val="accent1"/>
+            </a:fillRef>
+            <a:effectRef idx="0">
+              <a:schemeClr val="accent1"/>
+            </a:effectRef>
+            <a:fontRef idx="minor">
+              <a:schemeClr val="tx1"/>
+            </a:fontRef>
+          </p:style>
+        </p:cxnSp>
+        <p:cxnSp>
+          <p:nvCxnSpPr>
+            <p:cNvPr id="12" name="Straight Connector 11"/>
+            <p:cNvCxnSpPr/>
+            <p:nvPr/>
+          </p:nvCxnSpPr>
+          <p:spPr>
+            <a:xfrm>
+              <a:off x="5992754" y="3582887"/>
+              <a:ext cx="6070292" cy="0"/>
+            </a:xfrm>
+            <a:prstGeom prst="line">
+              <a:avLst/>
+            </a:prstGeom>
+            <a:ln>
+              <a:solidFill>
+                <a:schemeClr val="bg1">
+                  <a:lumMod val="85000"/>
+                </a:schemeClr>
+              </a:solidFill>
+              <a:prstDash val="sysDash"/>
+            </a:ln>
+          </p:spPr>
+          <p:style>
+            <a:lnRef idx="1">
+              <a:schemeClr val="accent1"/>
+            </a:lnRef>
+            <a:fillRef idx="0">
+              <a:schemeClr val="accent1"/>
+            </a:fillRef>
+            <a:effectRef idx="0">
+              <a:schemeClr val="accent1"/>
+            </a:effectRef>
+            <a:fontRef idx="minor">
+              <a:schemeClr val="tx1"/>
+            </a:fontRef>
+          </p:style>
+        </p:cxnSp>
+      </p:grpSp>
+      <p:sp>
+        <p:nvSpPr>
+          <p:cNvPr id="14" name="TextBox 13"/>
+          <p:cNvSpPr txBox="1"/>
+          <p:nvPr/>
+        </p:nvSpPr>
+        <p:spPr>
+          <a:xfrm>
+            <a:off x="8589818" y="3428998"/>
+            <a:ext cx="184731" cy="369332"/>
+          </a:xfrm>
+          <a:prstGeom prst="rect">
+            <a:avLst/>
+          </a:prstGeom>
+          <a:noFill/>
+        </p:spPr>
+        <p:txBody>
+          <a:bodyPr wrap="none" rtlCol="0">
+            <a:spAutoFit/>
+          </a:bodyPr>
+          <a:lstStyle/>
+          <a:p>
+            <a:endParaRPr lang="en-IN" dirty="0"/>
+          </a:p>
+        </p:txBody>
+      </p:sp>
+      <p:sp>
+        <p:nvSpPr>
+          <p:cNvPr id="16" name="Rectangle 1"/>
+          <p:cNvSpPr>
+            <a:spLocks noChangeArrowheads="1"/>
+          </p:cNvSpPr>
+          <p:nvPr/>
+        </p:nvSpPr>
+        <p:spPr bwMode="auto">
+          <a:xfrm>
+            <a:off x="6727372" y="4139124"/>
+            <a:ext cx="1308371" cy="307777"/>
+          </a:xfrm>
+          <a:prstGeom prst="rect">
+            <a:avLst/>
+          </a:prstGeom>
+          <a:solidFill>
+            <a:srgbClr val="33CC33"/>
+          </a:solidFill>
+          <a:ln>
+            <a:solidFill>
+              <a:srgbClr val="006600"/>
+            </a:solidFill>
+          </a:ln>
+          <a:effectLst/>
+        </p:spPr>
+        <p:txBody>
+          <a:bodyPr vert="horz" wrap="none" lIns="91440" tIns="45720" rIns="91440" bIns="45720" numCol="1" anchor="ctr" anchorCtr="0" compatLnSpc="1">
+            <a:prstTxWarp prst="textNoShape">
+              <a:avLst/>
+            </a:prstTxWarp>
+            <a:spAutoFit/>
+          </a:bodyPr>
+          <a:lstStyle/>
+          <a:p>
+            <a:pPr marL="0" marR="0" lvl="0" indent="0" algn="l" defTabSz="914400" rtl="0" eaLnBrk="1" fontAlgn="base" latinLnBrk="0" hangingPunct="1">
+              <a:lnSpc>
+                <a:spcPct val="100000"/>
+              </a:lnSpc>
+              <a:spcBef>
+                <a:spcPct val="0"/>
+              </a:spcBef>
+              <a:spcAft>
+                <a:spcPct val="0"/>
+              </a:spcAft>
+              <a:buClrTx/>
+              <a:buSzTx/>
+              <a:buFontTx/>
+              <a:buNone/>
+              <a:tabLst/>
+            </a:pPr>
+            <a:r>
+              <a:rPr lang="en-US" sz="1400" dirty="0">
+                <a:latin typeface="Bahnschrift Light" pitchFamily="34" charset="0"/>
+                <a:ea typeface="Arial Unicode MS" pitchFamily="34" charset="-128"/>
+                <a:cs typeface="Arial Unicode MS" pitchFamily="34" charset="-128"/>
+              </a:rPr>
+              <a:t>Dense Sparse</a:t>
+            </a:r>
+          </a:p>
+        </p:txBody>
+      </p:sp>
     </p:spTree>
     <p:extLst>
       <p:ext uri="{BB962C8B-B14F-4D97-AF65-F5344CB8AC3E}">
@@ -9402,7 +9613,7 @@
         <p:cNvPr id="1" name="">
           <a:extLst>
             <a:ext uri="{FF2B5EF4-FFF2-40B4-BE49-F238E27FC236}">
-              <a16:creationId xmlns="" xmlns:a16="http://schemas.microsoft.com/office/drawing/2014/main" id="{9A00AC01-0D1B-4670-B29D-784BF9417E63}"/>
+              <a16:creationId xmlns:a16="http://schemas.microsoft.com/office/drawing/2014/main" xmlns="" id="{9A00AC01-0D1B-4670-B29D-784BF9417E63}"/>
             </a:ext>
           </a:extLst>
         </p:cNvPr>
@@ -9864,7 +10075,7 @@
         <p:cNvPr id="1" name="">
           <a:extLst>
             <a:ext uri="{FF2B5EF4-FFF2-40B4-BE49-F238E27FC236}">
-              <a16:creationId xmlns="" xmlns:a16="http://schemas.microsoft.com/office/drawing/2014/main" id="{9A00AC01-0D1B-4670-B29D-784BF9417E63}"/>
+              <a16:creationId xmlns:a16="http://schemas.microsoft.com/office/drawing/2014/main" xmlns="" id="{9A00AC01-0D1B-4670-B29D-784BF9417E63}"/>
             </a:ext>
           </a:extLst>
         </p:cNvPr>
@@ -11372,7 +11583,7 @@
         <p:cNvPr id="1" name="">
           <a:extLst>
             <a:ext uri="{FF2B5EF4-FFF2-40B4-BE49-F238E27FC236}">
-              <a16:creationId xmlns="" xmlns:a16="http://schemas.microsoft.com/office/drawing/2014/main" id="{9A00AC01-0D1B-4670-B29D-784BF9417E63}"/>
+              <a16:creationId xmlns:a16="http://schemas.microsoft.com/office/drawing/2014/main" xmlns="" id="{9A00AC01-0D1B-4670-B29D-784BF9417E63}"/>
             </a:ext>
           </a:extLst>
         </p:cNvPr>
@@ -13234,7 +13445,7 @@
         <p:cNvPr id="1" name="">
           <a:extLst>
             <a:ext uri="{FF2B5EF4-FFF2-40B4-BE49-F238E27FC236}">
-              <a16:creationId xmlns="" xmlns:a16="http://schemas.microsoft.com/office/drawing/2014/main" id="{9A00AC01-0D1B-4670-B29D-784BF9417E63}"/>
+              <a16:creationId xmlns:a16="http://schemas.microsoft.com/office/drawing/2014/main" xmlns="" id="{9A00AC01-0D1B-4670-B29D-784BF9417E63}"/>
             </a:ext>
           </a:extLst>
         </p:cNvPr>
@@ -13272,15 +13483,7 @@
           <a:p>
             <a:r>
               <a:rPr lang="en-US" sz="1600" dirty="0"/>
-              <a:t>Well</a:t>
-            </a:r>
-            <a:r>
-              <a:rPr lang="en-US" sz="1600" dirty="0"/>
-              <a:t>, computers are incredibly efficient at processing numbers</a:t>
-            </a:r>
-            <a:r>
-              <a:rPr lang="en-US" sz="1600" dirty="0"/>
-              <a:t>.</a:t>
+              <a:t>Well, computers are incredibly efficient at processing numbers.</a:t>
             </a:r>
           </a:p>
           <a:p>
@@ -13424,7 +13627,7 @@
         <p:cNvPr id="1" name="">
           <a:extLst>
             <a:ext uri="{FF2B5EF4-FFF2-40B4-BE49-F238E27FC236}">
-              <a16:creationId xmlns="" xmlns:a16="http://schemas.microsoft.com/office/drawing/2014/main" id="{9A00AC01-0D1B-4670-B29D-784BF9417E63}"/>
+              <a16:creationId xmlns:a16="http://schemas.microsoft.com/office/drawing/2014/main" xmlns="" id="{9A00AC01-0D1B-4670-B29D-784BF9417E63}"/>
             </a:ext>
           </a:extLst>
         </p:cNvPr>
@@ -14222,7 +14425,7 @@
         <p:cNvPr id="1" name="">
           <a:extLst>
             <a:ext uri="{FF2B5EF4-FFF2-40B4-BE49-F238E27FC236}">
-              <a16:creationId xmlns="" xmlns:a16="http://schemas.microsoft.com/office/drawing/2014/main" id="{9A00AC01-0D1B-4670-B29D-784BF9417E63}"/>
+              <a16:creationId xmlns:a16="http://schemas.microsoft.com/office/drawing/2014/main" xmlns="" id="{9A00AC01-0D1B-4670-B29D-784BF9417E63}"/>
             </a:ext>
           </a:extLst>
         </p:cNvPr>
@@ -14824,15 +15027,7 @@
           <a:p>
             <a:r>
               <a:rPr lang="en-US" sz="1600" dirty="0"/>
-              <a:t>These types of data require more advanced techniques to extract meaningful features that can </a:t>
-            </a:r>
-            <a:r>
-              <a:rPr lang="en-US" sz="1600" dirty="0"/>
-              <a:t>better represent the required </a:t>
-            </a:r>
-            <a:r>
-              <a:rPr lang="en-US" sz="1600" dirty="0"/>
-              <a:t>patterns in the data</a:t>
+              <a:t>These types of data require more advanced techniques to extract meaningful features that can better represent the required patterns in the data</a:t>
             </a:r>
             <a:r>
               <a:rPr lang="en-US" dirty="0"/>
@@ -14870,7 +15065,7 @@
         <p:cNvPr id="1" name="">
           <a:extLst>
             <a:ext uri="{FF2B5EF4-FFF2-40B4-BE49-F238E27FC236}">
-              <a16:creationId xmlns="" xmlns:a16="http://schemas.microsoft.com/office/drawing/2014/main" id="{9A00AC01-0D1B-4670-B29D-784BF9417E63}"/>
+              <a16:creationId xmlns:a16="http://schemas.microsoft.com/office/drawing/2014/main" xmlns="" id="{9A00AC01-0D1B-4670-B29D-784BF9417E63}"/>
             </a:ext>
           </a:extLst>
         </p:cNvPr>
@@ -15114,7 +15309,7 @@
         <p:cNvPr id="1" name="">
           <a:extLst>
             <a:ext uri="{FF2B5EF4-FFF2-40B4-BE49-F238E27FC236}">
-              <a16:creationId xmlns="" xmlns:a16="http://schemas.microsoft.com/office/drawing/2014/main" id="{9A00AC01-0D1B-4670-B29D-784BF9417E63}"/>
+              <a16:creationId xmlns:a16="http://schemas.microsoft.com/office/drawing/2014/main" xmlns="" id="{9A00AC01-0D1B-4670-B29D-784BF9417E63}"/>
             </a:ext>
           </a:extLst>
         </p:cNvPr>
@@ -15812,7 +16007,7 @@
         <p:cNvPr id="1" name="">
           <a:extLst>
             <a:ext uri="{FF2B5EF4-FFF2-40B4-BE49-F238E27FC236}">
-              <a16:creationId xmlns="" xmlns:a16="http://schemas.microsoft.com/office/drawing/2014/main" id="{9A00AC01-0D1B-4670-B29D-784BF9417E63}"/>
+              <a16:creationId xmlns:a16="http://schemas.microsoft.com/office/drawing/2014/main" xmlns="" id="{9A00AC01-0D1B-4670-B29D-784BF9417E63}"/>
             </a:ext>
           </a:extLst>
         </p:cNvPr>
@@ -16070,7 +16265,7 @@
         <p:cNvPr id="1" name="">
           <a:extLst>
             <a:ext uri="{FF2B5EF4-FFF2-40B4-BE49-F238E27FC236}">
-              <a16:creationId xmlns="" xmlns:a16="http://schemas.microsoft.com/office/drawing/2014/main" id="{95CE01EE-9B82-1A8D-6A71-28923D9F4DBF}"/>
+              <a16:creationId xmlns:a16="http://schemas.microsoft.com/office/drawing/2014/main" xmlns="" id="{95CE01EE-9B82-1A8D-6A71-28923D9F4DBF}"/>
             </a:ext>
           </a:extLst>
         </p:cNvPr>
@@ -16634,7 +16829,7 @@
         <p:cNvPr id="1" name="">
           <a:extLst>
             <a:ext uri="{FF2B5EF4-FFF2-40B4-BE49-F238E27FC236}">
-              <a16:creationId xmlns="" xmlns:a16="http://schemas.microsoft.com/office/drawing/2014/main" id="{9A00AC01-0D1B-4670-B29D-784BF9417E63}"/>
+              <a16:creationId xmlns:a16="http://schemas.microsoft.com/office/drawing/2014/main" xmlns="" id="{9A00AC01-0D1B-4670-B29D-784BF9417E63}"/>
             </a:ext>
           </a:extLst>
         </p:cNvPr>
@@ -17200,7 +17395,7 @@
         <p:cNvPr id="1" name="">
           <a:extLst>
             <a:ext uri="{FF2B5EF4-FFF2-40B4-BE49-F238E27FC236}">
-              <a16:creationId xmlns="" xmlns:a16="http://schemas.microsoft.com/office/drawing/2014/main" id="{9A00AC01-0D1B-4670-B29D-784BF9417E63}"/>
+              <a16:creationId xmlns:a16="http://schemas.microsoft.com/office/drawing/2014/main" xmlns="" id="{9A00AC01-0D1B-4670-B29D-784BF9417E63}"/>
             </a:ext>
           </a:extLst>
         </p:cNvPr>
@@ -19599,7 +19794,7 @@
         <p:cNvPr id="1" name="">
           <a:extLst>
             <a:ext uri="{FF2B5EF4-FFF2-40B4-BE49-F238E27FC236}">
-              <a16:creationId xmlns="" xmlns:a16="http://schemas.microsoft.com/office/drawing/2014/main" id="{9A00AC01-0D1B-4670-B29D-784BF9417E63}"/>
+              <a16:creationId xmlns:a16="http://schemas.microsoft.com/office/drawing/2014/main" xmlns="" id="{9A00AC01-0D1B-4670-B29D-784BF9417E63}"/>
             </a:ext>
           </a:extLst>
         </p:cNvPr>
@@ -19993,7 +20188,7 @@
         <p:cNvPr id="1" name="">
           <a:extLst>
             <a:ext uri="{FF2B5EF4-FFF2-40B4-BE49-F238E27FC236}">
-              <a16:creationId xmlns="" xmlns:a16="http://schemas.microsoft.com/office/drawing/2014/main" id="{9A00AC01-0D1B-4670-B29D-784BF9417E63}"/>
+              <a16:creationId xmlns:a16="http://schemas.microsoft.com/office/drawing/2014/main" xmlns="" id="{9A00AC01-0D1B-4670-B29D-784BF9417E63}"/>
             </a:ext>
           </a:extLst>
         </p:cNvPr>
@@ -21010,7 +21205,7 @@
         <p:cNvPr id="1" name="">
           <a:extLst>
             <a:ext uri="{FF2B5EF4-FFF2-40B4-BE49-F238E27FC236}">
-              <a16:creationId xmlns="" xmlns:a16="http://schemas.microsoft.com/office/drawing/2014/main" id="{9A00AC01-0D1B-4670-B29D-784BF9417E63}"/>
+              <a16:creationId xmlns:a16="http://schemas.microsoft.com/office/drawing/2014/main" xmlns="" id="{9A00AC01-0D1B-4670-B29D-784BF9417E63}"/>
             </a:ext>
           </a:extLst>
         </p:cNvPr>
@@ -21289,7 +21484,7 @@
         <p:cNvPr id="1" name="">
           <a:extLst>
             <a:ext uri="{FF2B5EF4-FFF2-40B4-BE49-F238E27FC236}">
-              <a16:creationId xmlns="" xmlns:a16="http://schemas.microsoft.com/office/drawing/2014/main" id="{9A00AC01-0D1B-4670-B29D-784BF9417E63}"/>
+              <a16:creationId xmlns:a16="http://schemas.microsoft.com/office/drawing/2014/main" xmlns="" id="{9A00AC01-0D1B-4670-B29D-784BF9417E63}"/>
             </a:ext>
           </a:extLst>
         </p:cNvPr>
@@ -21332,7 +21527,7 @@
         <p:cNvPr id="1" name="">
           <a:extLst>
             <a:ext uri="{FF2B5EF4-FFF2-40B4-BE49-F238E27FC236}">
-              <a16:creationId xmlns="" xmlns:a16="http://schemas.microsoft.com/office/drawing/2014/main" id="{9A00AC01-0D1B-4670-B29D-784BF9417E63}"/>
+              <a16:creationId xmlns:a16="http://schemas.microsoft.com/office/drawing/2014/main" xmlns="" id="{9A00AC01-0D1B-4670-B29D-784BF9417E63}"/>
             </a:ext>
           </a:extLst>
         </p:cNvPr>
@@ -22570,7 +22765,7 @@
         <p:cNvPr id="1" name="">
           <a:extLst>
             <a:ext uri="{FF2B5EF4-FFF2-40B4-BE49-F238E27FC236}">
-              <a16:creationId xmlns="" xmlns:a16="http://schemas.microsoft.com/office/drawing/2014/main" id="{9A00AC01-0D1B-4670-B29D-784BF9417E63}"/>
+              <a16:creationId xmlns:a16="http://schemas.microsoft.com/office/drawing/2014/main" xmlns="" id="{9A00AC01-0D1B-4670-B29D-784BF9417E63}"/>
             </a:ext>
           </a:extLst>
         </p:cNvPr>
@@ -22902,7 +23097,7 @@
         <p:cNvPr id="1" name="">
           <a:extLst>
             <a:ext uri="{FF2B5EF4-FFF2-40B4-BE49-F238E27FC236}">
-              <a16:creationId xmlns="" xmlns:a16="http://schemas.microsoft.com/office/drawing/2014/main" id="{9A00AC01-0D1B-4670-B29D-784BF9417E63}"/>
+              <a16:creationId xmlns:a16="http://schemas.microsoft.com/office/drawing/2014/main" xmlns="" id="{9A00AC01-0D1B-4670-B29D-784BF9417E63}"/>
             </a:ext>
           </a:extLst>
         </p:cNvPr>
@@ -23299,7 +23494,7 @@
         <p:cNvPr id="1" name="">
           <a:extLst>
             <a:ext uri="{FF2B5EF4-FFF2-40B4-BE49-F238E27FC236}">
-              <a16:creationId xmlns="" xmlns:a16="http://schemas.microsoft.com/office/drawing/2014/main" id="{9A00AC01-0D1B-4670-B29D-784BF9417E63}"/>
+              <a16:creationId xmlns:a16="http://schemas.microsoft.com/office/drawing/2014/main" xmlns="" id="{9A00AC01-0D1B-4670-B29D-784BF9417E63}"/>
             </a:ext>
           </a:extLst>
         </p:cNvPr>
@@ -25328,7 +25523,7 @@
         <p:cNvPr id="1" name="">
           <a:extLst>
             <a:ext uri="{FF2B5EF4-FFF2-40B4-BE49-F238E27FC236}">
-              <a16:creationId xmlns="" xmlns:a16="http://schemas.microsoft.com/office/drawing/2014/main" id="{9A00AC01-0D1B-4670-B29D-784BF9417E63}"/>
+              <a16:creationId xmlns:a16="http://schemas.microsoft.com/office/drawing/2014/main" xmlns="" id="{9A00AC01-0D1B-4670-B29D-784BF9417E63}"/>
             </a:ext>
           </a:extLst>
         </p:cNvPr>
@@ -25348,7 +25543,7 @@
           <p:cNvPr id="4" name="Footer Placeholder 3">
             <a:extLst>
               <a:ext uri="{FF2B5EF4-FFF2-40B4-BE49-F238E27FC236}">
-                <a16:creationId xmlns="" xmlns:a16="http://schemas.microsoft.com/office/drawing/2014/main" id="{CF61D508-5ADB-85A0-C55A-A34AD3B36759}"/>
+                <a16:creationId xmlns:a16="http://schemas.microsoft.com/office/drawing/2014/main" xmlns="" id="{CF61D508-5ADB-85A0-C55A-A34AD3B36759}"/>
               </a:ext>
             </a:extLst>
           </p:cNvPr>
@@ -25776,7 +25971,7 @@
         <p:cNvPr id="1" name="">
           <a:extLst>
             <a:ext uri="{FF2B5EF4-FFF2-40B4-BE49-F238E27FC236}">
-              <a16:creationId xmlns="" xmlns:a16="http://schemas.microsoft.com/office/drawing/2014/main" id="{9A00AC01-0D1B-4670-B29D-784BF9417E63}"/>
+              <a16:creationId xmlns:a16="http://schemas.microsoft.com/office/drawing/2014/main" xmlns="" id="{9A00AC01-0D1B-4670-B29D-784BF9417E63}"/>
             </a:ext>
           </a:extLst>
         </p:cNvPr>
@@ -26241,7 +26436,7 @@
         <p:cNvPr id="1" name="">
           <a:extLst>
             <a:ext uri="{FF2B5EF4-FFF2-40B4-BE49-F238E27FC236}">
-              <a16:creationId xmlns="" xmlns:a16="http://schemas.microsoft.com/office/drawing/2014/main" id="{9A00AC01-0D1B-4670-B29D-784BF9417E63}"/>
+              <a16:creationId xmlns:a16="http://schemas.microsoft.com/office/drawing/2014/main" xmlns="" id="{9A00AC01-0D1B-4670-B29D-784BF9417E63}"/>
             </a:ext>
           </a:extLst>
         </p:cNvPr>
@@ -27140,7 +27335,7 @@
         <p:cNvPr id="1" name="">
           <a:extLst>
             <a:ext uri="{FF2B5EF4-FFF2-40B4-BE49-F238E27FC236}">
-              <a16:creationId xmlns="" xmlns:a16="http://schemas.microsoft.com/office/drawing/2014/main" id="{9A00AC01-0D1B-4670-B29D-784BF9417E63}"/>
+              <a16:creationId xmlns:a16="http://schemas.microsoft.com/office/drawing/2014/main" xmlns="" id="{9A00AC01-0D1B-4670-B29D-784BF9417E63}"/>
             </a:ext>
           </a:extLst>
         </p:cNvPr>
@@ -27237,15 +27432,7 @@
                     <a:srgbClr val="15C2FF"/>
                   </a:solidFill>
                 </a:rPr>
-                <a:t>embedding_function</a:t>
-              </a:r>
-              <a:r>
-                <a:rPr lang="en-IN" dirty="0">
-                  <a:solidFill>
-                    <a:srgbClr val="15C2FF"/>
-                  </a:solidFill>
-                </a:rPr>
-                <a:t>=embeddings</a:t>
+                <a:t>embedding_function=embeddings</a:t>
               </a:r>
               <a:r>
                 <a:rPr lang="en-IN" dirty="0"/>
@@ -27804,7 +27991,7 @@
         <p:cNvPr id="1" name="">
           <a:extLst>
             <a:ext uri="{FF2B5EF4-FFF2-40B4-BE49-F238E27FC236}">
-              <a16:creationId xmlns="" xmlns:a16="http://schemas.microsoft.com/office/drawing/2014/main" id="{9A00AC01-0D1B-4670-B29D-784BF9417E63}"/>
+              <a16:creationId xmlns:a16="http://schemas.microsoft.com/office/drawing/2014/main" xmlns="" id="{9A00AC01-0D1B-4670-B29D-784BF9417E63}"/>
             </a:ext>
           </a:extLst>
         </p:cNvPr>
@@ -28580,7 +28767,7 @@
         <p:cNvPr id="1" name="">
           <a:extLst>
             <a:ext uri="{FF2B5EF4-FFF2-40B4-BE49-F238E27FC236}">
-              <a16:creationId xmlns="" xmlns:a16="http://schemas.microsoft.com/office/drawing/2014/main" id="{9A00AC01-0D1B-4670-B29D-784BF9417E63}"/>
+              <a16:creationId xmlns:a16="http://schemas.microsoft.com/office/drawing/2014/main" xmlns="" id="{9A00AC01-0D1B-4670-B29D-784BF9417E63}"/>
             </a:ext>
           </a:extLst>
         </p:cNvPr>
@@ -28600,7 +28787,7 @@
           <p:cNvPr id="4" name="Footer Placeholder 3">
             <a:extLst>
               <a:ext uri="{FF2B5EF4-FFF2-40B4-BE49-F238E27FC236}">
-                <a16:creationId xmlns="" xmlns:a16="http://schemas.microsoft.com/office/drawing/2014/main" id="{CF61D508-5ADB-85A0-C55A-A34AD3B36759}"/>
+                <a16:creationId xmlns:a16="http://schemas.microsoft.com/office/drawing/2014/main" xmlns="" id="{CF61D508-5ADB-85A0-C55A-A34AD3B36759}"/>
               </a:ext>
             </a:extLst>
           </p:cNvPr>
@@ -29077,7 +29264,7 @@
         <p:cNvPr id="1" name="">
           <a:extLst>
             <a:ext uri="{FF2B5EF4-FFF2-40B4-BE49-F238E27FC236}">
-              <a16:creationId xmlns="" xmlns:a16="http://schemas.microsoft.com/office/drawing/2014/main" id="{9A00AC01-0D1B-4670-B29D-784BF9417E63}"/>
+              <a16:creationId xmlns:a16="http://schemas.microsoft.com/office/drawing/2014/main" xmlns="" id="{9A00AC01-0D1B-4670-B29D-784BF9417E63}"/>
             </a:ext>
           </a:extLst>
         </p:cNvPr>
@@ -29097,7 +29284,7 @@
           <p:cNvPr id="4" name="Footer Placeholder 3">
             <a:extLst>
               <a:ext uri="{FF2B5EF4-FFF2-40B4-BE49-F238E27FC236}">
-                <a16:creationId xmlns="" xmlns:a16="http://schemas.microsoft.com/office/drawing/2014/main" id="{CF61D508-5ADB-85A0-C55A-A34AD3B36759}"/>
+                <a16:creationId xmlns:a16="http://schemas.microsoft.com/office/drawing/2014/main" xmlns="" id="{CF61D508-5ADB-85A0-C55A-A34AD3B36759}"/>
               </a:ext>
             </a:extLst>
           </p:cNvPr>
@@ -30593,7 +30780,7 @@
         <p:cNvPr id="1" name="">
           <a:extLst>
             <a:ext uri="{FF2B5EF4-FFF2-40B4-BE49-F238E27FC236}">
-              <a16:creationId xmlns="" xmlns:a16="http://schemas.microsoft.com/office/drawing/2014/main" id="{9A00AC01-0D1B-4670-B29D-784BF9417E63}"/>
+              <a16:creationId xmlns:a16="http://schemas.microsoft.com/office/drawing/2014/main" xmlns="" id="{9A00AC01-0D1B-4670-B29D-784BF9417E63}"/>
             </a:ext>
           </a:extLst>
         </p:cNvPr>
@@ -31236,7 +31423,7 @@
         <p:cNvPr id="1" name="">
           <a:extLst>
             <a:ext uri="{FF2B5EF4-FFF2-40B4-BE49-F238E27FC236}">
-              <a16:creationId xmlns="" xmlns:a16="http://schemas.microsoft.com/office/drawing/2014/main" id="{9A00AC01-0D1B-4670-B29D-784BF9417E63}"/>
+              <a16:creationId xmlns:a16="http://schemas.microsoft.com/office/drawing/2014/main" xmlns="" id="{9A00AC01-0D1B-4670-B29D-784BF9417E63}"/>
             </a:ext>
           </a:extLst>
         </p:cNvPr>
@@ -31256,7 +31443,7 @@
           <p:cNvPr id="4" name="Footer Placeholder 3">
             <a:extLst>
               <a:ext uri="{FF2B5EF4-FFF2-40B4-BE49-F238E27FC236}">
-                <a16:creationId xmlns="" xmlns:a16="http://schemas.microsoft.com/office/drawing/2014/main" id="{CF61D508-5ADB-85A0-C55A-A34AD3B36759}"/>
+                <a16:creationId xmlns:a16="http://schemas.microsoft.com/office/drawing/2014/main" xmlns="" id="{CF61D508-5ADB-85A0-C55A-A34AD3B36759}"/>
               </a:ext>
             </a:extLst>
           </p:cNvPr>
@@ -31615,7 +31802,7 @@
         <p:cNvPr id="1" name="">
           <a:extLst>
             <a:ext uri="{FF2B5EF4-FFF2-40B4-BE49-F238E27FC236}">
-              <a16:creationId xmlns="" xmlns:a16="http://schemas.microsoft.com/office/drawing/2014/main" id="{9A00AC01-0D1B-4670-B29D-784BF9417E63}"/>
+              <a16:creationId xmlns:a16="http://schemas.microsoft.com/office/drawing/2014/main" xmlns="" id="{9A00AC01-0D1B-4670-B29D-784BF9417E63}"/>
             </a:ext>
           </a:extLst>
         </p:cNvPr>
@@ -31635,7 +31822,7 @@
           <p:cNvPr id="4" name="Footer Placeholder 3">
             <a:extLst>
               <a:ext uri="{FF2B5EF4-FFF2-40B4-BE49-F238E27FC236}">
-                <a16:creationId xmlns="" xmlns:a16="http://schemas.microsoft.com/office/drawing/2014/main" id="{CF61D508-5ADB-85A0-C55A-A34AD3B36759}"/>
+                <a16:creationId xmlns:a16="http://schemas.microsoft.com/office/drawing/2014/main" xmlns="" id="{CF61D508-5ADB-85A0-C55A-A34AD3B36759}"/>
               </a:ext>
             </a:extLst>
           </p:cNvPr>
@@ -32368,7 +32555,7 @@
         <p:cNvPr id="1" name="">
           <a:extLst>
             <a:ext uri="{FF2B5EF4-FFF2-40B4-BE49-F238E27FC236}">
-              <a16:creationId xmlns="" xmlns:a16="http://schemas.microsoft.com/office/drawing/2014/main" id="{9A00AC01-0D1B-4670-B29D-784BF9417E63}"/>
+              <a16:creationId xmlns:a16="http://schemas.microsoft.com/office/drawing/2014/main" xmlns="" id="{9A00AC01-0D1B-4670-B29D-784BF9417E63}"/>
             </a:ext>
           </a:extLst>
         </p:cNvPr>
@@ -32388,7 +32575,7 @@
           <p:cNvPr id="4" name="Footer Placeholder 3">
             <a:extLst>
               <a:ext uri="{FF2B5EF4-FFF2-40B4-BE49-F238E27FC236}">
-                <a16:creationId xmlns="" xmlns:a16="http://schemas.microsoft.com/office/drawing/2014/main" id="{CF61D508-5ADB-85A0-C55A-A34AD3B36759}"/>
+                <a16:creationId xmlns:a16="http://schemas.microsoft.com/office/drawing/2014/main" xmlns="" id="{CF61D508-5ADB-85A0-C55A-A34AD3B36759}"/>
               </a:ext>
             </a:extLst>
           </p:cNvPr>
@@ -32975,7 +33162,7 @@
         <p:cNvPr id="1" name="">
           <a:extLst>
             <a:ext uri="{FF2B5EF4-FFF2-40B4-BE49-F238E27FC236}">
-              <a16:creationId xmlns="" xmlns:a16="http://schemas.microsoft.com/office/drawing/2014/main" id="{9A00AC01-0D1B-4670-B29D-784BF9417E63}"/>
+              <a16:creationId xmlns:a16="http://schemas.microsoft.com/office/drawing/2014/main" xmlns="" id="{9A00AC01-0D1B-4670-B29D-784BF9417E63}"/>
             </a:ext>
           </a:extLst>
         </p:cNvPr>
@@ -33665,7 +33852,7 @@
         <p:cNvPr id="1" name="">
           <a:extLst>
             <a:ext uri="{FF2B5EF4-FFF2-40B4-BE49-F238E27FC236}">
-              <a16:creationId xmlns="" xmlns:a16="http://schemas.microsoft.com/office/drawing/2014/main" id="{9A00AC01-0D1B-4670-B29D-784BF9417E63}"/>
+              <a16:creationId xmlns:a16="http://schemas.microsoft.com/office/drawing/2014/main" xmlns="" id="{9A00AC01-0D1B-4670-B29D-784BF9417E63}"/>
             </a:ext>
           </a:extLst>
         </p:cNvPr>
@@ -34139,7 +34326,7 @@
         <p:cNvPr id="1" name="">
           <a:extLst>
             <a:ext uri="{FF2B5EF4-FFF2-40B4-BE49-F238E27FC236}">
-              <a16:creationId xmlns="" xmlns:a16="http://schemas.microsoft.com/office/drawing/2014/main" id="{9A00AC01-0D1B-4670-B29D-784BF9417E63}"/>
+              <a16:creationId xmlns:a16="http://schemas.microsoft.com/office/drawing/2014/main" xmlns="" id="{9A00AC01-0D1B-4670-B29D-784BF9417E63}"/>
             </a:ext>
           </a:extLst>
         </p:cNvPr>
@@ -35133,7 +35320,7 @@
         <p:cNvPr id="1" name="">
           <a:extLst>
             <a:ext uri="{FF2B5EF4-FFF2-40B4-BE49-F238E27FC236}">
-              <a16:creationId xmlns="" xmlns:a16="http://schemas.microsoft.com/office/drawing/2014/main" id="{9A00AC01-0D1B-4670-B29D-784BF9417E63}"/>
+              <a16:creationId xmlns:a16="http://schemas.microsoft.com/office/drawing/2014/main" xmlns="" id="{9A00AC01-0D1B-4670-B29D-784BF9417E63}"/>
             </a:ext>
           </a:extLst>
         </p:cNvPr>
@@ -35786,7 +35973,7 @@
         <p:cNvPr id="1" name="">
           <a:extLst>
             <a:ext uri="{FF2B5EF4-FFF2-40B4-BE49-F238E27FC236}">
-              <a16:creationId xmlns="" xmlns:a16="http://schemas.microsoft.com/office/drawing/2014/main" id="{9A00AC01-0D1B-4670-B29D-784BF9417E63}"/>
+              <a16:creationId xmlns:a16="http://schemas.microsoft.com/office/drawing/2014/main" xmlns="" id="{9A00AC01-0D1B-4670-B29D-784BF9417E63}"/>
             </a:ext>
           </a:extLst>
         </p:cNvPr>
@@ -35888,31 +36075,7 @@
               <a:rPr lang="en-US" sz="1600" dirty="0">
                 <a:latin typeface="Bahnschrift Light" pitchFamily="34" charset="0"/>
               </a:rPr>
-              <a:t>AI applications such as </a:t>
-            </a:r>
-            <a:r>
-              <a:rPr lang="en-US" sz="1600" dirty="0">
-                <a:latin typeface="Bahnschrift Light" pitchFamily="34" charset="0"/>
-              </a:rPr>
-              <a:t>LLM, </a:t>
-            </a:r>
-            <a:r>
-              <a:rPr lang="en-US" sz="1600" dirty="0">
-                <a:latin typeface="Bahnschrift Light" pitchFamily="34" charset="0"/>
-              </a:rPr>
-              <a:t>Generative AI and semantic Search require large amounts of data to </a:t>
-            </a:r>
-            <a:r>
-              <a:rPr lang="en-US" sz="1600" dirty="0">
-                <a:latin typeface="Bahnschrift Light" pitchFamily="34" charset="0"/>
-              </a:rPr>
-              <a:t>train and </a:t>
-            </a:r>
-            <a:r>
-              <a:rPr lang="en-US" sz="1600" dirty="0">
-                <a:latin typeface="Bahnschrift Light" pitchFamily="34" charset="0"/>
-              </a:rPr>
-              <a:t>operate.</a:t>
+              <a:t>AI applications such as LLM, Generative AI and semantic Search require large amounts of data to train and operate.</a:t>
             </a:r>
           </a:p>
           <a:p>
@@ -35938,42 +36101,15 @@
               <a:rPr lang="en-US" sz="1600" dirty="0">
                 <a:latin typeface="Bahnschrift Light" pitchFamily="34" charset="0"/>
               </a:rPr>
-              <a:t>Many of the latest AI applications rely on vector </a:t>
-            </a:r>
+              <a:t>Many of the latest AI applications rely on vector embedding.</a:t>
+            </a:r>
+          </a:p>
+          <a:p>
             <a:r>
               <a:rPr lang="en-US" sz="1600" dirty="0">
                 <a:latin typeface="Bahnschrift Light" pitchFamily="34" charset="0"/>
               </a:rPr>
-              <a:t>embedding.</a:t>
-            </a:r>
-            <a:endParaRPr lang="en-US" sz="1600" dirty="0">
-              <a:latin typeface="Bahnschrift Light" pitchFamily="34" charset="0"/>
-            </a:endParaRPr>
-          </a:p>
-          <a:p>
-            <a:r>
-              <a:rPr lang="en-US" sz="1600" dirty="0">
-                <a:latin typeface="Bahnschrift Light" pitchFamily="34" charset="0"/>
-              </a:rPr>
-              <a:t>Chat bots, question answering systems and machine translation rely on vector </a:t>
-            </a:r>
-            <a:r>
-              <a:rPr lang="en-US" sz="1600" dirty="0">
-                <a:latin typeface="Bahnschrift Light" pitchFamily="34" charset="0"/>
-              </a:rPr>
-              <a:t>embedding , </a:t>
-            </a:r>
-            <a:r>
-              <a:rPr lang="en-US" sz="1600" dirty="0">
-                <a:latin typeface="Bahnschrift Light" pitchFamily="34" charset="0"/>
-              </a:rPr>
-              <a:t>means converting text to numbers that carry within themselves semantic information</a:t>
-            </a:r>
-            <a:r>
-              <a:rPr lang="en-US" sz="1600" dirty="0">
-                <a:latin typeface="Bahnschrift Light" pitchFamily="34" charset="0"/>
-              </a:rPr>
-              <a:t>.</a:t>
+              <a:t>Chat bots, question answering systems and machine translation rely on vector embedding , means converting text to numbers that carry within themselves semantic information.</a:t>
             </a:r>
           </a:p>
           <a:p>
@@ -36076,7 +36212,7 @@
         <p:cNvPr id="1" name="">
           <a:extLst>
             <a:ext uri="{FF2B5EF4-FFF2-40B4-BE49-F238E27FC236}">
-              <a16:creationId xmlns="" xmlns:a16="http://schemas.microsoft.com/office/drawing/2014/main" id="{9A00AC01-0D1B-4670-B29D-784BF9417E63}"/>
+              <a16:creationId xmlns:a16="http://schemas.microsoft.com/office/drawing/2014/main" xmlns="" id="{9A00AC01-0D1B-4670-B29D-784BF9417E63}"/>
             </a:ext>
           </a:extLst>
         </p:cNvPr>
@@ -36124,25 +36260,7 @@
               <a:rPr lang="en-US" sz="1600" dirty="0">
                 <a:latin typeface="Bahnschrift Light" pitchFamily="34" charset="0"/>
               </a:rPr>
-              <a:t>One application that we built in</a:t>
-            </a:r>
-            <a:r>
-              <a:rPr lang="en-US" sz="1600" dirty="0">
-                <a:latin typeface="Bahnschrift Light" pitchFamily="34" charset="0"/>
-              </a:rPr>
-              <a:t>. </a:t>
-            </a:r>
-            <a:r>
-              <a:rPr lang="en-US" sz="1600" dirty="0">
-                <a:latin typeface="Bahnschrift Light" pitchFamily="34" charset="0"/>
-              </a:rPr>
-              <a:t>The </a:t>
-            </a:r>
-            <a:r>
-              <a:rPr lang="en-US" sz="1600" dirty="0">
-                <a:latin typeface="Bahnschrift Light" pitchFamily="34" charset="0"/>
-              </a:rPr>
-              <a:t>first part of the course was a book recommendation system</a:t>
+              <a:t>One application that we built in. The first part of the course was a book recommendation system</a:t>
             </a:r>
             <a:r>
               <a:rPr lang="en-US" dirty="0" smtClean="0">
@@ -36185,39 +36303,15 @@
               <a:rPr lang="en-US" sz="1600" dirty="0">
                 <a:latin typeface="Bahnschrift Light" pitchFamily="34" charset="0"/>
               </a:rPr>
-              <a:t>which contained information about thousands of books</a:t>
-            </a:r>
+              <a:t>which contained information about thousands of books. We transformed the book description into vectors using an AI model and stored both the description and its corresponding embedding in a CSV file.</a:t>
+            </a:r>
+          </a:p>
+          <a:p>
             <a:r>
               <a:rPr lang="en-US" sz="1600" dirty="0">
                 <a:latin typeface="Bahnschrift Light" pitchFamily="34" charset="0"/>
               </a:rPr>
-              <a:t>. </a:t>
-            </a:r>
-            <a:r>
-              <a:rPr lang="en-US" sz="1600" dirty="0">
-                <a:latin typeface="Bahnschrift Light" pitchFamily="34" charset="0"/>
-              </a:rPr>
-              <a:t>We </a:t>
-            </a:r>
-            <a:r>
-              <a:rPr lang="en-US" sz="1600" dirty="0">
-                <a:latin typeface="Bahnschrift Light" pitchFamily="34" charset="0"/>
-              </a:rPr>
-              <a:t>transformed the book description into vectors using an AI model and stored both the description and its corresponding embedding in a CSV file.</a:t>
-            </a:r>
-          </a:p>
-          <a:p>
-            <a:r>
-              <a:rPr lang="en-US" sz="1600" dirty="0">
-                <a:latin typeface="Bahnschrift Light" pitchFamily="34" charset="0"/>
-              </a:rPr>
-              <a:t>These are the </a:t>
-            </a:r>
-            <a:r>
-              <a:rPr lang="en-US" sz="1600" dirty="0">
-                <a:latin typeface="Bahnschrift Light" pitchFamily="34" charset="0"/>
-              </a:rPr>
-              <a:t>embedding.</a:t>
+              <a:t>These are the embedding.</a:t>
             </a:r>
           </a:p>
           <a:p>
@@ -36238,31 +36332,7 @@
               <a:rPr lang="en-US" sz="1600" dirty="0">
                 <a:latin typeface="Bahnschrift Light" pitchFamily="34" charset="0"/>
               </a:rPr>
-              <a:t>description, embedding and calculates the closest </a:t>
-            </a:r>
-            <a:r>
-              <a:rPr lang="en-US" sz="1600" dirty="0">
-                <a:latin typeface="Bahnschrift Light" pitchFamily="34" charset="0"/>
-              </a:rPr>
-              <a:t>embedding. Similar </a:t>
-            </a:r>
-            <a:r>
-              <a:rPr lang="en-US" sz="1600" dirty="0">
-                <a:latin typeface="Bahnschrift Light" pitchFamily="34" charset="0"/>
-              </a:rPr>
-              <a:t>embeddings suggest comparable text descriptions</a:t>
-            </a:r>
-            <a:r>
-              <a:rPr lang="en-US" sz="1600" dirty="0">
-                <a:latin typeface="Bahnschrift Light" pitchFamily="34" charset="0"/>
-              </a:rPr>
-              <a:t>. The </a:t>
-            </a:r>
-            <a:r>
-              <a:rPr lang="en-US" sz="1600" dirty="0">
-                <a:latin typeface="Bahnschrift Light" pitchFamily="34" charset="0"/>
-              </a:rPr>
-              <a:t>application operated satisfactory, but storing extensive data in a CSV file proved to be highly</a:t>
+              <a:t>description, embedding and calculates the closest embedding. Similar embeddings suggest comparable text descriptions. The application operated satisfactory, but storing extensive data in a CSV file proved to be highly</a:t>
             </a:r>
           </a:p>
           <a:p>
@@ -36322,7 +36392,7 @@
         <p:cNvPr id="1" name="">
           <a:extLst>
             <a:ext uri="{FF2B5EF4-FFF2-40B4-BE49-F238E27FC236}">
-              <a16:creationId xmlns="" xmlns:a16="http://schemas.microsoft.com/office/drawing/2014/main" id="{9A00AC01-0D1B-4670-B29D-784BF9417E63}"/>
+              <a16:creationId xmlns:a16="http://schemas.microsoft.com/office/drawing/2014/main" xmlns="" id="{9A00AC01-0D1B-4670-B29D-784BF9417E63}"/>
             </a:ext>
           </a:extLst>
         </p:cNvPr>
@@ -36394,13 +36464,7 @@
               <a:rPr lang="en-US" sz="1600" dirty="0">
                 <a:latin typeface="Bahnschrift Light" pitchFamily="34" charset="0"/>
               </a:rPr>
-              <a:t>There are many vector databases available, both free and </a:t>
-            </a:r>
-            <a:r>
-              <a:rPr lang="en-US" sz="1600" dirty="0">
-                <a:latin typeface="Bahnschrift Light" pitchFamily="34" charset="0"/>
-              </a:rPr>
-              <a:t>commercial. </a:t>
+              <a:t>There are many vector databases available, both free and commercial. </a:t>
             </a:r>
             <a:r>
               <a:rPr lang="en-US" dirty="0" smtClean="0">
@@ -36489,19 +36553,7 @@
               <a:rPr lang="en-US" sz="1600" dirty="0">
                 <a:latin typeface="Bahnschrift Light" pitchFamily="34" charset="0"/>
               </a:rPr>
-              <a:t>It provides fast and efficient semantic search over these vector embeddings by integrating </a:t>
-            </a:r>
-            <a:r>
-              <a:rPr lang="en-US" sz="1600" dirty="0">
-                <a:latin typeface="Bahnschrift Light" pitchFamily="34" charset="0"/>
-              </a:rPr>
-              <a:t>OpenAI LLM </a:t>
-            </a:r>
-            <a:r>
-              <a:rPr lang="en-US" sz="1600" dirty="0">
-                <a:latin typeface="Bahnschrift Light" pitchFamily="34" charset="0"/>
-              </a:rPr>
-              <a:t>with Pinecone.</a:t>
+              <a:t>It provides fast and efficient semantic search over these vector embeddings by integrating OpenAI LLM with Pinecone.</a:t>
             </a:r>
           </a:p>
           <a:p>
@@ -36577,13 +36629,7 @@
               <a:rPr lang="en-US" sz="1600" dirty="0">
                 <a:latin typeface="Bahnschrift Light" pitchFamily="34" charset="0"/>
               </a:rPr>
-              <a:t>is data that does not have a fixed schema, such as text images and audio</a:t>
-            </a:r>
-            <a:r>
-              <a:rPr lang="en-US" sz="1600" dirty="0">
-                <a:latin typeface="Bahnschrift Light" pitchFamily="34" charset="0"/>
-              </a:rPr>
-              <a:t>.</a:t>
+              <a:t>is data that does not have a fixed schema, such as text images and audio.</a:t>
             </a:r>
           </a:p>
           <a:p>
@@ -36598,34 +36644,13 @@
               </a:rPr>
               <a:t>SQL databases, </a:t>
             </a:r>
-            <a:endParaRPr lang="en-US" sz="1600" dirty="0">
-              <a:latin typeface="Bahnschrift Light" pitchFamily="34" charset="0"/>
-            </a:endParaRPr>
           </a:p>
           <a:p>
             <a:r>
               <a:rPr lang="en-US" sz="1600" dirty="0">
                 <a:latin typeface="Bahnschrift Light" pitchFamily="34" charset="0"/>
               </a:rPr>
-              <a:t>on </a:t>
-            </a:r>
-            <a:r>
-              <a:rPr lang="en-US" sz="1600" dirty="0">
-                <a:latin typeface="Bahnschrift Light" pitchFamily="34" charset="0"/>
-              </a:rPr>
-              <a:t>the other hand, are designed to store and query structured data, which has a </a:t>
-            </a:r>
-            <a:r>
-              <a:rPr lang="en-US" sz="1600" dirty="0">
-                <a:latin typeface="Bahnschrift Light" pitchFamily="34" charset="0"/>
-              </a:rPr>
-              <a:t>fixed schema</a:t>
-            </a:r>
-            <a:r>
-              <a:rPr lang="en-US" sz="1600" dirty="0">
-                <a:latin typeface="Bahnschrift Light" pitchFamily="34" charset="0"/>
-              </a:rPr>
-              <a:t>.</a:t>
+              <a:t>on the other hand, are designed to store and query structured data, which has a fixed schema.</a:t>
             </a:r>
           </a:p>
           <a:p>
@@ -36696,7 +36721,7 @@
         <p:cNvPr id="1" name="">
           <a:extLst>
             <a:ext uri="{FF2B5EF4-FFF2-40B4-BE49-F238E27FC236}">
-              <a16:creationId xmlns="" xmlns:a16="http://schemas.microsoft.com/office/drawing/2014/main" id="{9A00AC01-0D1B-4670-B29D-784BF9417E63}"/>
+              <a16:creationId xmlns:a16="http://schemas.microsoft.com/office/drawing/2014/main" xmlns="" id="{9A00AC01-0D1B-4670-B29D-784BF9417E63}"/>
             </a:ext>
           </a:extLst>
         </p:cNvPr>
@@ -36859,11 +36884,7 @@
             </a:r>
             <a:r>
               <a:rPr lang="en-US" sz="1600" dirty="0"/>
-              <a:t>is a mathematical object characterized by both magnitude and direction</a:t>
-            </a:r>
-            <a:r>
-              <a:rPr lang="en-US" sz="1600" dirty="0"/>
-              <a:t>.</a:t>
+              <a:t>is a mathematical object characterized by both magnitude and direction.</a:t>
             </a:r>
           </a:p>
           <a:p>
@@ -36876,45 +36897,13 @@
           <a:p>
             <a:r>
               <a:rPr lang="en-US" sz="1600" dirty="0"/>
-              <a:t>It </a:t>
-            </a:r>
+              <a:t>It is represented as an arrow pointing from one point to another in space. The arrow has a starting point and an end point.</a:t>
+            </a:r>
+          </a:p>
+          <a:p>
             <a:r>
               <a:rPr lang="en-US" sz="1600" dirty="0"/>
-              <a:t>is </a:t>
-            </a:r>
-            <a:r>
-              <a:rPr lang="en-US" sz="1600" dirty="0"/>
-              <a:t>represented </a:t>
-            </a:r>
-            <a:r>
-              <a:rPr lang="en-US" sz="1600" dirty="0"/>
-              <a:t>as an arrow pointing from one point to another in </a:t>
-            </a:r>
-            <a:r>
-              <a:rPr lang="en-US" sz="1600" dirty="0"/>
-              <a:t>space. The </a:t>
-            </a:r>
-            <a:r>
-              <a:rPr lang="en-US" sz="1600" dirty="0"/>
-              <a:t>arrow has a starting point and an end point.</a:t>
-            </a:r>
-          </a:p>
-          <a:p>
-            <a:r>
-              <a:rPr lang="en-US" sz="1600" dirty="0"/>
-              <a:t>The </a:t>
-            </a:r>
-            <a:r>
-              <a:rPr lang="en-US" sz="1600" dirty="0"/>
-              <a:t>length of the arrow corresponds to the magnitude of the vector, while its orientation in </a:t>
-            </a:r>
-            <a:r>
-              <a:rPr lang="en-US" sz="1600" dirty="0"/>
-              <a:t>space indicates </a:t>
-            </a:r>
-            <a:r>
-              <a:rPr lang="en-US" sz="1600" dirty="0"/>
-              <a:t>the direction</a:t>
+              <a:t>The length of the arrow corresponds to the magnitude of the vector, while its orientation in space indicates the direction</a:t>
             </a:r>
             <a:r>
               <a:rPr lang="en-US" sz="1600" dirty="0">
@@ -37444,7 +37433,7 @@
         <p:cNvPr id="1" name="">
           <a:extLst>
             <a:ext uri="{FF2B5EF4-FFF2-40B4-BE49-F238E27FC236}">
-              <a16:creationId xmlns="" xmlns:a16="http://schemas.microsoft.com/office/drawing/2014/main" id="{9A00AC01-0D1B-4670-B29D-784BF9417E63}"/>
+              <a16:creationId xmlns:a16="http://schemas.microsoft.com/office/drawing/2014/main" xmlns="" id="{9A00AC01-0D1B-4670-B29D-784BF9417E63}"/>
             </a:ext>
           </a:extLst>
         </p:cNvPr>
@@ -38702,7 +38691,7 @@
   <a:extraClrSchemeLst/>
   <a:extLst>
     <a:ext uri="{05A4C25C-085E-4340-85A3-A5531E510DB2}">
-      <thm15:themeFamily xmlns="" xmlns:thm15="http://schemas.microsoft.com/office/thememl/2012/main" name="Office Theme" id="{62F939B6-93AF-4DB8-9C6B-D6C7DFDC589F}" vid="{4A3C46E8-61CC-4603-A589-7422A47A8E4A}"/>
+      <thm15:themeFamily xmlns:thm15="http://schemas.microsoft.com/office/thememl/2012/main" xmlns="" name="Office Theme" id="{62F939B6-93AF-4DB8-9C6B-D6C7DFDC589F}" vid="{4A3C46E8-61CC-4603-A589-7422A47A8E4A}"/>
     </a:ext>
   </a:extLst>
 </a:theme>
@@ -38997,7 +38986,7 @@
   <a:extraClrSchemeLst/>
   <a:extLst>
     <a:ext uri="{05A4C25C-085E-4340-85A3-A5531E510DB2}">
-      <thm15:themeFamily xmlns="" xmlns:thm15="http://schemas.microsoft.com/office/thememl/2012/main" name="Office Theme" id="{62F939B6-93AF-4DB8-9C6B-D6C7DFDC589F}" vid="{4A3C46E8-61CC-4603-A589-7422A47A8E4A}"/>
+      <thm15:themeFamily xmlns:thm15="http://schemas.microsoft.com/office/thememl/2012/main" xmlns="" name="Office Theme" id="{62F939B6-93AF-4DB8-9C6B-D6C7DFDC589F}" vid="{4A3C46E8-61CC-4603-A589-7422A47A8E4A}"/>
     </a:ext>
   </a:extLst>
 </a:theme>

</xml_diff>